<commit_message>
Rewrite the opening statement as a dialogue, drop volume figures, loosen spacing
The 'o que voces querem automatizar?' slide argued in the abstract. It now
stages the exchange literally — the question asked, the answer that always
comes back, why that answer is a solution guess, and the question to ask
instead.

Volume counts (12.000/mes, 300/mes, 21 mil) are replaced by 'alto volume' /
'baixo volume' throughout. An invented number invites the room to argue the
number instead of the method.

Several slides were packed to the edge of their content box. Cut the
seven-question reveals to one line each, shortened three callouts, and
raised row padding and gaps on the question list, the interview quotes, the
tool layers, the kit and the three-box slide. Both flowcharts get tighter
viewBoxes so they use the width their column actually has.

Co-Authored-By: Claude Opus 5 <noreply@anthropic.com>
Claude-Session: https://claude.ai/code/session_01MoQxsSguKqzeKVWx2SGcrP
</commit_message>
<xml_diff>
--- a/talks/serasa-ia-automacao/deck.pptx
+++ b/talks/serasa-ia-automacao/deck.pptx
@@ -1131,7 +1131,7 @@
           <a:p>
             <a:r>
               <a:rPr lang="en-US" dirty="0"/>
-              <a:t>Slide de pontuação. Fale a pergunta errada em voz alta e espere o riso de reconhecimento. A linha de baixo é o roteiro — aponte pra ela. ~1,5 min.</a:t>
+              <a:t>Slide de pontuação. Encene o diálogo: faça a pergunta errada em voz alta e dê a resposta que sempre vem. A linha de baixo é o roteiro — aponte pra ela. ~1,5 min.</a:t>
             </a:r>
             <a:endParaRPr lang="en-US" dirty="0"/>
           </a:p>
@@ -6362,12 +6362,12 @@
         </p:nvSpPr>
         <p:spPr>
           <a:xfrm>
-            <a:off x="658368" y="5468112"/>
-            <a:ext cx="10874959" cy="822960"/>
+            <a:off x="658368" y="5559552"/>
+            <a:ext cx="10874959" cy="530352"/>
           </a:xfrm>
           <a:prstGeom prst="roundRect">
             <a:avLst>
-              <a:gd name="adj" fmla="val 11111"/>
+              <a:gd name="adj" fmla="val 17241"/>
             </a:avLst>
           </a:prstGeom>
           <a:solidFill>
@@ -6389,8 +6389,8 @@
         </p:nvSpPr>
         <p:spPr>
           <a:xfrm>
-            <a:off x="658368" y="5468112"/>
-            <a:ext cx="45720" cy="822960"/>
+            <a:off x="658368" y="5559552"/>
+            <a:ext cx="45720" cy="530352"/>
           </a:xfrm>
           <a:prstGeom prst="rect">
             <a:avLst/>
@@ -6414,8 +6414,8 @@
         </p:nvSpPr>
         <p:spPr>
           <a:xfrm>
-            <a:off x="914400" y="5559552"/>
-            <a:ext cx="7315200" cy="201168"/>
+            <a:off x="914400" y="5687568"/>
+            <a:ext cx="10362895" cy="274320"/>
           </a:xfrm>
           <a:prstGeom prst="rect">
             <a:avLst/>
@@ -6428,153 +6428,114 @@
           <a:lstStyle/>
           <a:p>
             <a:pPr indent="0" marL="0">
-              <a:buNone/>
-            </a:pPr>
-            <a:r>
-              <a:rPr lang="en-US" sz="950" b="1" spc="180" kern="0" dirty="0">
-                <a:solidFill>
-                  <a:srgbClr val="E80070"/>
-                </a:solidFill>
-                <a:latin typeface="Arial" pitchFamily="34" charset="0"/>
-                <a:ea typeface="Arial" pitchFamily="34" charset="-122"/>
-                <a:cs typeface="Arial" pitchFamily="34" charset="-120"/>
-              </a:rPr>
-              <a:t>TRÊS CONFUSÕES DE VOCABULÁRIO QUE ATRAPALHAM A CONVERSA</a:t>
-            </a:r>
-            <a:endParaRPr lang="en-US" sz="950" dirty="0"/>
+              <a:lnSpc>
+                <a:spcPts val="1600"/>
+              </a:lnSpc>
+              <a:buNone/>
+            </a:pPr>
+            <a:r>
+              <a:rPr lang="en-US" sz="1200" b="1" dirty="0">
+                <a:solidFill>
+                  <a:srgbClr val="16224E"/>
+                </a:solidFill>
+                <a:latin typeface="Arial" pitchFamily="34" charset="0"/>
+                <a:ea typeface="Arial" pitchFamily="34" charset="-122"/>
+                <a:cs typeface="Arial" pitchFamily="34" charset="-120"/>
+              </a:rPr>
+              <a:t>Claude Code não é modelo</a:t>
+            </a:r>
+            <a:pPr indent="0" marL="0">
+              <a:lnSpc>
+                <a:spcPts val="1600"/>
+              </a:lnSpc>
+              <a:buNone/>
+            </a:pPr>
+            <a:r>
+              <a:rPr lang="en-US" sz="1200" dirty="0">
+                <a:solidFill>
+                  <a:srgbClr val="16224E"/>
+                </a:solidFill>
+                <a:latin typeface="Arial" pitchFamily="34" charset="0"/>
+                <a:ea typeface="Arial" pitchFamily="34" charset="-122"/>
+                <a:cs typeface="Arial" pitchFamily="34" charset="-120"/>
+              </a:rPr>
+              <a:t> — é agente. </a:t>
+            </a:r>
+            <a:pPr indent="0" marL="0">
+              <a:lnSpc>
+                <a:spcPts val="1600"/>
+              </a:lnSpc>
+              <a:buNone/>
+            </a:pPr>
+            <a:r>
+              <a:rPr lang="en-US" sz="1200" b="1" dirty="0">
+                <a:solidFill>
+                  <a:srgbClr val="16224E"/>
+                </a:solidFill>
+                <a:latin typeface="Arial" pitchFamily="34" charset="0"/>
+                <a:ea typeface="Arial" pitchFamily="34" charset="-122"/>
+                <a:cs typeface="Arial" pitchFamily="34" charset="-120"/>
+              </a:rPr>
+              <a:t>Cursor não é orquestrador</a:t>
+            </a:r>
+            <a:pPr indent="0" marL="0">
+              <a:lnSpc>
+                <a:spcPts val="1600"/>
+              </a:lnSpc>
+              <a:buNone/>
+            </a:pPr>
+            <a:r>
+              <a:rPr lang="en-US" sz="1200" dirty="0">
+                <a:solidFill>
+                  <a:srgbClr val="16224E"/>
+                </a:solidFill>
+                <a:latin typeface="Arial" pitchFamily="34" charset="0"/>
+                <a:ea typeface="Arial" pitchFamily="34" charset="-122"/>
+                <a:cs typeface="Arial" pitchFamily="34" charset="-120"/>
+              </a:rPr>
+              <a:t> — é editor com agente. </a:t>
+            </a:r>
+            <a:pPr indent="0" marL="0">
+              <a:lnSpc>
+                <a:spcPts val="1600"/>
+              </a:lnSpc>
+              <a:buNone/>
+            </a:pPr>
+            <a:r>
+              <a:rPr lang="en-US" sz="1200" b="1" dirty="0">
+                <a:solidFill>
+                  <a:srgbClr val="16224E"/>
+                </a:solidFill>
+                <a:latin typeface="Arial" pitchFamily="34" charset="0"/>
+                <a:ea typeface="Arial" pitchFamily="34" charset="-122"/>
+                <a:cs typeface="Arial" pitchFamily="34" charset="-120"/>
+              </a:rPr>
+              <a:t>GitHub Actions é gatilho</a:t>
+            </a:r>
+            <a:pPr indent="0" marL="0">
+              <a:lnSpc>
+                <a:spcPts val="1600"/>
+              </a:lnSpc>
+              <a:buNone/>
+            </a:pPr>
+            <a:r>
+              <a:rPr lang="en-US" sz="1200" dirty="0">
+                <a:solidFill>
+                  <a:srgbClr val="16224E"/>
+                </a:solidFill>
+                <a:latin typeface="Arial" pitchFamily="34" charset="0"/>
+                <a:ea typeface="Arial" pitchFamily="34" charset="-122"/>
+                <a:cs typeface="Arial" pitchFamily="34" charset="-120"/>
+              </a:rPr>
+              <a:t>, não orquestrador.</a:t>
+            </a:r>
+            <a:endParaRPr lang="en-US" sz="1200" dirty="0"/>
           </a:p>
         </p:txBody>
       </p:sp>
       <p:sp>
         <p:nvSpPr>
           <p:cNvPr id="63" name="Text 61"/>
-          <p:cNvSpPr/>
-          <p:nvPr/>
-        </p:nvSpPr>
-        <p:spPr>
-          <a:xfrm>
-            <a:off x="914400" y="5779008"/>
-            <a:ext cx="10362895" cy="438912"/>
-          </a:xfrm>
-          <a:prstGeom prst="rect">
-            <a:avLst/>
-          </a:prstGeom>
-          <a:noFill/>
-          <a:ln/>
-        </p:spPr>
-        <p:txBody>
-          <a:bodyPr wrap="square" lIns="0" tIns="0" rIns="0" bIns="0" rtlCol="0" anchor="t"/>
-          <a:lstStyle/>
-          <a:p>
-            <a:pPr indent="0" marL="0">
-              <a:lnSpc>
-                <a:spcPts val="1600"/>
-              </a:lnSpc>
-              <a:buNone/>
-            </a:pPr>
-            <a:r>
-              <a:rPr lang="en-US" sz="1200" b="1" dirty="0">
-                <a:solidFill>
-                  <a:srgbClr val="16224E"/>
-                </a:solidFill>
-                <a:latin typeface="Arial" pitchFamily="34" charset="0"/>
-                <a:ea typeface="Arial" pitchFamily="34" charset="-122"/>
-                <a:cs typeface="Arial" pitchFamily="34" charset="-120"/>
-              </a:rPr>
-              <a:t>Claude Code não é modelo</a:t>
-            </a:r>
-            <a:pPr indent="0" marL="0">
-              <a:lnSpc>
-                <a:spcPts val="1600"/>
-              </a:lnSpc>
-              <a:buNone/>
-            </a:pPr>
-            <a:r>
-              <a:rPr lang="en-US" sz="1200" dirty="0">
-                <a:solidFill>
-                  <a:srgbClr val="16224E"/>
-                </a:solidFill>
-                <a:latin typeface="Arial" pitchFamily="34" charset="0"/>
-                <a:ea typeface="Arial" pitchFamily="34" charset="-122"/>
-                <a:cs typeface="Arial" pitchFamily="34" charset="-120"/>
-              </a:rPr>
-              <a:t> — é um agente que usa modelos. </a:t>
-            </a:r>
-            <a:pPr indent="0" marL="0">
-              <a:lnSpc>
-                <a:spcPts val="1600"/>
-              </a:lnSpc>
-              <a:buNone/>
-            </a:pPr>
-            <a:r>
-              <a:rPr lang="en-US" sz="1200" b="1" dirty="0">
-                <a:solidFill>
-                  <a:srgbClr val="16224E"/>
-                </a:solidFill>
-                <a:latin typeface="Arial" pitchFamily="34" charset="0"/>
-                <a:ea typeface="Arial" pitchFamily="34" charset="-122"/>
-                <a:cs typeface="Arial" pitchFamily="34" charset="-120"/>
-              </a:rPr>
-              <a:t>Cursor não é orquestrador</a:t>
-            </a:r>
-            <a:pPr indent="0" marL="0">
-              <a:lnSpc>
-                <a:spcPts val="1600"/>
-              </a:lnSpc>
-              <a:buNone/>
-            </a:pPr>
-            <a:r>
-              <a:rPr lang="en-US" sz="1200" dirty="0">
-                <a:solidFill>
-                  <a:srgbClr val="16224E"/>
-                </a:solidFill>
-                <a:latin typeface="Arial" pitchFamily="34" charset="0"/>
-                <a:ea typeface="Arial" pitchFamily="34" charset="-122"/>
-                <a:cs typeface="Arial" pitchFamily="34" charset="-120"/>
-              </a:rPr>
-              <a:t> — é editor com agente dentro. </a:t>
-            </a:r>
-            <a:pPr indent="0" marL="0">
-              <a:lnSpc>
-                <a:spcPts val="1600"/>
-              </a:lnSpc>
-              <a:buNone/>
-            </a:pPr>
-            <a:r>
-              <a:rPr lang="en-US" sz="1200" b="1" dirty="0">
-                <a:solidFill>
-                  <a:srgbClr val="16224E"/>
-                </a:solidFill>
-                <a:latin typeface="Arial" pitchFamily="34" charset="0"/>
-                <a:ea typeface="Arial" pitchFamily="34" charset="-122"/>
-                <a:cs typeface="Arial" pitchFamily="34" charset="-120"/>
-              </a:rPr>
-              <a:t>GitHub Actions não orquestra IA</a:t>
-            </a:r>
-            <a:pPr indent="0" marL="0">
-              <a:lnSpc>
-                <a:spcPts val="1600"/>
-              </a:lnSpc>
-              <a:buNone/>
-            </a:pPr>
-            <a:r>
-              <a:rPr lang="en-US" sz="1200" dirty="0">
-                <a:solidFill>
-                  <a:srgbClr val="16224E"/>
-                </a:solidFill>
-                <a:latin typeface="Arial" pitchFamily="34" charset="0"/>
-                <a:ea typeface="Arial" pitchFamily="34" charset="-122"/>
-                <a:cs typeface="Arial" pitchFamily="34" charset="-120"/>
-              </a:rPr>
-              <a:t> — é gatilho: ótimo pra disparar, ruim pra manter estado entre etapas.</a:t>
-            </a:r>
-            <a:endParaRPr lang="en-US" sz="1200" dirty="0"/>
-          </a:p>
-        </p:txBody>
-      </p:sp>
-      <p:sp>
-        <p:nvSpPr>
-          <p:cNvPr id="64" name="Text 62"/>
           <p:cNvSpPr/>
           <p:nvPr/>
         </p:nvSpPr>
@@ -6613,7 +6574,7 @@
       </p:sp>
       <p:sp>
         <p:nvSpPr>
-          <p:cNvPr id="65" name="Text 63"/>
+          <p:cNvPr id="64" name="Text 62"/>
           <p:cNvSpPr/>
           <p:nvPr/>
         </p:nvSpPr>
@@ -8010,7 +7971,7 @@
                 <a:ea typeface="Arial" pitchFamily="34" charset="-122"/>
                 <a:cs typeface="Arial" pitchFamily="34" charset="-120"/>
               </a:rPr>
-              <a:t>: entrada, saída, dono, volume/mês, exceções, custo do erro.</a:t>
+              <a:t>: entrada, saída, dono, frequência, exceções, custo do erro.</a:t>
             </a:r>
             <a:endParaRPr lang="en-US" sz="1050" dirty="0"/>
           </a:p>
@@ -10193,8 +10154,100 @@
         </p:nvSpPr>
         <p:spPr>
           <a:xfrm>
+            <a:off x="658368" y="868680"/>
+            <a:ext cx="8229600" cy="274320"/>
+          </a:xfrm>
+          <a:prstGeom prst="rect">
+            <a:avLst/>
+          </a:prstGeom>
+          <a:noFill/>
+          <a:ln/>
+        </p:spPr>
+        <p:txBody>
+          <a:bodyPr wrap="square" lIns="0" tIns="0" rIns="0" bIns="0" rtlCol="0" anchor="ctr"/>
+          <a:lstStyle/>
+          <a:p>
+            <a:pPr indent="0" marL="0">
+              <a:buNone/>
+            </a:pPr>
+            <a:r>
+              <a:rPr lang="en-US" sz="1100" b="1" spc="220" kern="0" dirty="0">
+                <a:solidFill>
+                  <a:srgbClr val="FF8FC0"/>
+                </a:solidFill>
+                <a:latin typeface="Arial" pitchFamily="34" charset="0"/>
+                <a:ea typeface="Arial" pitchFamily="34" charset="-122"/>
+                <a:cs typeface="Arial" pitchFamily="34" charset="-120"/>
+              </a:rPr>
+              <a:t>COMO ISSO COMEÇA ERRADO</a:t>
+            </a:r>
+            <a:endParaRPr lang="en-US" sz="1100" dirty="0"/>
+          </a:p>
+        </p:txBody>
+      </p:sp>
+      <p:sp>
+        <p:nvSpPr>
+          <p:cNvPr id="3" name="Text 1"/>
+          <p:cNvSpPr/>
+          <p:nvPr/>
+        </p:nvSpPr>
+        <p:spPr>
+          <a:xfrm>
             <a:off x="658368" y="1234440"/>
-            <a:ext cx="8229600" cy="274320"/>
+            <a:ext cx="10058400" cy="640080"/>
+          </a:xfrm>
+          <a:prstGeom prst="rect">
+            <a:avLst/>
+          </a:prstGeom>
+          <a:noFill/>
+          <a:ln/>
+        </p:spPr>
+        <p:txBody>
+          <a:bodyPr wrap="square" lIns="0" tIns="0" rIns="0" bIns="0" rtlCol="0" anchor="t"/>
+          <a:lstStyle/>
+          <a:p>
+            <a:pPr indent="0" marL="0">
+              <a:buNone/>
+            </a:pPr>
+            <a:r>
+              <a:rPr lang="en-US" sz="3200" b="1" dirty="0">
+                <a:solidFill>
+                  <a:srgbClr val="FFFFFF"/>
+                </a:solidFill>
+                <a:latin typeface="Arial" pitchFamily="34" charset="0"/>
+                <a:ea typeface="Arial" pitchFamily="34" charset="-122"/>
+                <a:cs typeface="Arial" pitchFamily="34" charset="-120"/>
+              </a:rPr>
+              <a:t>A primeira pergunta é sempre </a:t>
+            </a:r>
+            <a:pPr indent="0" marL="0">
+              <a:buNone/>
+            </a:pPr>
+            <a:r>
+              <a:rPr lang="en-US" sz="3200" b="1" dirty="0">
+                <a:solidFill>
+                  <a:srgbClr val="FF8FC0"/>
+                </a:solidFill>
+                <a:latin typeface="Arial" pitchFamily="34" charset="0"/>
+                <a:ea typeface="Arial" pitchFamily="34" charset="-122"/>
+                <a:cs typeface="Arial" pitchFamily="34" charset="-120"/>
+              </a:rPr>
+              <a:t>a errada</a:t>
+            </a:r>
+            <a:endParaRPr lang="en-US" sz="3200" dirty="0"/>
+          </a:p>
+        </p:txBody>
+      </p:sp>
+      <p:sp>
+        <p:nvSpPr>
+          <p:cNvPr id="4" name="Text 2"/>
+          <p:cNvSpPr/>
+          <p:nvPr/>
+        </p:nvSpPr>
+        <p:spPr>
+          <a:xfrm>
+            <a:off x="658368" y="2340864"/>
+            <a:ext cx="1920240" cy="237744"/>
           </a:xfrm>
           <a:prstGeom prst="rect">
             <a:avLst/>
@@ -10210,30 +10263,228 @@
               <a:buNone/>
             </a:pPr>
             <a:r>
-              <a:rPr lang="en-US" sz="1100" b="1" spc="220" kern="0" dirty="0">
+              <a:rPr lang="en-US" sz="900" spc="120" kern="0" dirty="0">
+                <a:solidFill>
+                  <a:srgbClr val="C9B6D4"/>
+                </a:solidFill>
+                <a:latin typeface="Courier New" pitchFamily="34" charset="0"/>
+                <a:ea typeface="Courier New" pitchFamily="34" charset="-122"/>
+                <a:cs typeface="Courier New" pitchFamily="34" charset="-120"/>
+              </a:rPr>
+              <a:t>VOCÊ PERGUNTA</a:t>
+            </a:r>
+            <a:endParaRPr lang="en-US" sz="900" dirty="0"/>
+          </a:p>
+        </p:txBody>
+      </p:sp>
+      <p:sp>
+        <p:nvSpPr>
+          <p:cNvPr id="5" name="Text 3"/>
+          <p:cNvSpPr/>
+          <p:nvPr/>
+        </p:nvSpPr>
+        <p:spPr>
+          <a:xfrm>
+            <a:off x="2807208" y="2286000"/>
+            <a:ext cx="8229600" cy="384048"/>
+          </a:xfrm>
+          <a:prstGeom prst="rect">
+            <a:avLst/>
+          </a:prstGeom>
+          <a:noFill/>
+          <a:ln/>
+        </p:spPr>
+        <p:txBody>
+          <a:bodyPr wrap="square" lIns="0" tIns="0" rIns="0" bIns="0" rtlCol="0" anchor="t"/>
+          <a:lstStyle/>
+          <a:p>
+            <a:pPr indent="0" marL="0">
+              <a:buNone/>
+            </a:pPr>
+            <a:r>
+              <a:rPr lang="en-US" sz="1900" dirty="0">
+                <a:solidFill>
+                  <a:srgbClr val="FFFFFF"/>
+                </a:solidFill>
+                <a:latin typeface="Arial" pitchFamily="34" charset="0"/>
+                <a:ea typeface="Arial" pitchFamily="34" charset="-122"/>
+                <a:cs typeface="Arial" pitchFamily="34" charset="-120"/>
+              </a:rPr>
+              <a:t>“O que vocês querem automatizar?”</a:t>
+            </a:r>
+            <a:endParaRPr lang="en-US" sz="1900" dirty="0"/>
+          </a:p>
+        </p:txBody>
+      </p:sp>
+      <p:sp>
+        <p:nvSpPr>
+          <p:cNvPr id="6" name="Text 4"/>
+          <p:cNvSpPr/>
+          <p:nvPr/>
+        </p:nvSpPr>
+        <p:spPr>
+          <a:xfrm>
+            <a:off x="658368" y="2999232"/>
+            <a:ext cx="1920240" cy="237744"/>
+          </a:xfrm>
+          <a:prstGeom prst="rect">
+            <a:avLst/>
+          </a:prstGeom>
+          <a:noFill/>
+          <a:ln/>
+        </p:spPr>
+        <p:txBody>
+          <a:bodyPr wrap="square" lIns="0" tIns="0" rIns="0" bIns="0" rtlCol="0" anchor="ctr"/>
+          <a:lstStyle/>
+          <a:p>
+            <a:pPr indent="0" marL="0">
+              <a:buNone/>
+            </a:pPr>
+            <a:r>
+              <a:rPr lang="en-US" sz="900" spc="120" kern="0" dirty="0">
+                <a:solidFill>
+                  <a:srgbClr val="C9B6D4"/>
+                </a:solidFill>
+                <a:latin typeface="Courier New" pitchFamily="34" charset="0"/>
+                <a:ea typeface="Courier New" pitchFamily="34" charset="-122"/>
+                <a:cs typeface="Courier New" pitchFamily="34" charset="-120"/>
+              </a:rPr>
+              <a:t>A PESSOA RESPONDE</a:t>
+            </a:r>
+            <a:endParaRPr lang="en-US" sz="900" dirty="0"/>
+          </a:p>
+        </p:txBody>
+      </p:sp>
+      <p:sp>
+        <p:nvSpPr>
+          <p:cNvPr id="7" name="Text 5"/>
+          <p:cNvSpPr/>
+          <p:nvPr/>
+        </p:nvSpPr>
+        <p:spPr>
+          <a:xfrm>
+            <a:off x="2807208" y="2944368"/>
+            <a:ext cx="8229600" cy="384048"/>
+          </a:xfrm>
+          <a:prstGeom prst="rect">
+            <a:avLst/>
+          </a:prstGeom>
+          <a:noFill/>
+          <a:ln/>
+        </p:spPr>
+        <p:txBody>
+          <a:bodyPr wrap="square" lIns="0" tIns="0" rIns="0" bIns="0" rtlCol="0" anchor="t"/>
+          <a:lstStyle/>
+          <a:p>
+            <a:pPr indent="0" marL="0">
+              <a:buNone/>
+            </a:pPr>
+            <a:r>
+              <a:rPr lang="en-US" sz="1900" dirty="0">
+                <a:solidFill>
+                  <a:srgbClr val="FFFFFF"/>
+                </a:solidFill>
+                <a:latin typeface="Arial" pitchFamily="34" charset="0"/>
+                <a:ea typeface="Arial" pitchFamily="34" charset="-122"/>
+                <a:cs typeface="Arial" pitchFamily="34" charset="-120"/>
+              </a:rPr>
+              <a:t>“Queria um bot que respondesse os chamados.”</a:t>
+            </a:r>
+            <a:endParaRPr lang="en-US" sz="1900" dirty="0"/>
+          </a:p>
+        </p:txBody>
+      </p:sp>
+      <p:sp>
+        <p:nvSpPr>
+          <p:cNvPr id="8" name="Text 6"/>
+          <p:cNvSpPr/>
+          <p:nvPr/>
+        </p:nvSpPr>
+        <p:spPr>
+          <a:xfrm>
+            <a:off x="2807208" y="3621024"/>
+            <a:ext cx="7863840" cy="566928"/>
+          </a:xfrm>
+          <a:prstGeom prst="rect">
+            <a:avLst/>
+          </a:prstGeom>
+          <a:noFill/>
+          <a:ln/>
+        </p:spPr>
+        <p:txBody>
+          <a:bodyPr wrap="square" lIns="0" tIns="0" rIns="0" bIns="0" rtlCol="0" anchor="t"/>
+          <a:lstStyle/>
+          <a:p>
+            <a:pPr indent="0" marL="0">
+              <a:lnSpc>
+                <a:spcPts val="1900"/>
+              </a:lnSpc>
+              <a:buNone/>
+            </a:pPr>
+            <a:r>
+              <a:rPr lang="en-US" sz="1350" dirty="0">
+                <a:solidFill>
+                  <a:srgbClr val="E7DCEF"/>
+                </a:solidFill>
+                <a:latin typeface="Arial" pitchFamily="34" charset="0"/>
+                <a:ea typeface="Arial" pitchFamily="34" charset="-122"/>
+                <a:cs typeface="Arial" pitchFamily="34" charset="-120"/>
+              </a:rPr>
+              <a:t>Isso não é o processo. É um palpite de solução — e quem constrói em cima dele automatiza o que alguém imaginou, não o trabalho que existe.</a:t>
+            </a:r>
+            <a:endParaRPr lang="en-US" sz="1350" dirty="0"/>
+          </a:p>
+        </p:txBody>
+      </p:sp>
+      <p:sp>
+        <p:nvSpPr>
+          <p:cNvPr id="9" name="Text 7"/>
+          <p:cNvSpPr/>
+          <p:nvPr/>
+        </p:nvSpPr>
+        <p:spPr>
+          <a:xfrm>
+            <a:off x="658368" y="4526280"/>
+            <a:ext cx="1920240" cy="237744"/>
+          </a:xfrm>
+          <a:prstGeom prst="rect">
+            <a:avLst/>
+          </a:prstGeom>
+          <a:noFill/>
+          <a:ln/>
+        </p:spPr>
+        <p:txBody>
+          <a:bodyPr wrap="square" lIns="0" tIns="0" rIns="0" bIns="0" rtlCol="0" anchor="ctr"/>
+          <a:lstStyle/>
+          <a:p>
+            <a:pPr indent="0" marL="0">
+              <a:buNone/>
+            </a:pPr>
+            <a:r>
+              <a:rPr lang="en-US" sz="900" b="1" spc="120" kern="0" dirty="0">
                 <a:solidFill>
                   <a:srgbClr val="FF8FC0"/>
                 </a:solidFill>
-                <a:latin typeface="Arial" pitchFamily="34" charset="0"/>
-                <a:ea typeface="Arial" pitchFamily="34" charset="-122"/>
-                <a:cs typeface="Arial" pitchFamily="34" charset="-120"/>
-              </a:rPr>
-              <a:t>COMO ISSO COMEÇA ERRADO</a:t>
-            </a:r>
-            <a:endParaRPr lang="en-US" sz="1100" dirty="0"/>
-          </a:p>
-        </p:txBody>
-      </p:sp>
-      <p:sp>
-        <p:nvSpPr>
-          <p:cNvPr id="3" name="Text 1"/>
-          <p:cNvSpPr/>
-          <p:nvPr/>
-        </p:nvSpPr>
-        <p:spPr>
-          <a:xfrm>
-            <a:off x="658368" y="1627632"/>
-            <a:ext cx="9692640" cy="1554480"/>
+                <a:latin typeface="Courier New" pitchFamily="34" charset="0"/>
+                <a:ea typeface="Courier New" pitchFamily="34" charset="-122"/>
+                <a:cs typeface="Courier New" pitchFamily="34" charset="-120"/>
+              </a:rPr>
+              <a:t>PERGUNTE ASSIM</a:t>
+            </a:r>
+            <a:endParaRPr lang="en-US" sz="900" dirty="0"/>
+          </a:p>
+        </p:txBody>
+      </p:sp>
+      <p:sp>
+        <p:nvSpPr>
+          <p:cNvPr id="10" name="Text 8"/>
+          <p:cNvSpPr/>
+          <p:nvPr/>
+        </p:nvSpPr>
+        <p:spPr>
+          <a:xfrm>
+            <a:off x="2807208" y="4471416"/>
+            <a:ext cx="8229600" cy="411480"/>
           </a:xfrm>
           <a:prstGeom prst="rect">
             <a:avLst/>
@@ -10246,13 +10497,10 @@
           <a:lstStyle/>
           <a:p>
             <a:pPr indent="0" marL="0">
-              <a:lnSpc>
-                <a:spcPts val="3800"/>
-              </a:lnSpc>
-              <a:buNone/>
-            </a:pPr>
-            <a:r>
-              <a:rPr lang="en-US" sz="3200" b="1" dirty="0">
+              <a:buNone/>
+            </a:pPr>
+            <a:r>
+              <a:rPr lang="en-US" sz="1900" b="1" dirty="0">
                 <a:solidFill>
                   <a:srgbClr val="FFFFFF"/>
                 </a:solidFill>
@@ -10260,99 +10508,22 @@
                 <a:ea typeface="Arial" pitchFamily="34" charset="-122"/>
                 <a:cs typeface="Arial" pitchFamily="34" charset="-120"/>
               </a:rPr>
-              <a:t>“O que vocês querem automatizar?” só devolve </a:t>
-            </a:r>
-            <a:pPr indent="0" marL="0">
-              <a:lnSpc>
-                <a:spcPts val="3800"/>
-              </a:lnSpc>
-              <a:buNone/>
-            </a:pPr>
-            <a:r>
-              <a:rPr lang="en-US" sz="3200" b="1" dirty="0">
-                <a:solidFill>
-                  <a:srgbClr val="FF8FC0"/>
-                </a:solidFill>
-                <a:latin typeface="Arial" pitchFamily="34" charset="0"/>
-                <a:ea typeface="Arial" pitchFamily="34" charset="-122"/>
-                <a:cs typeface="Arial" pitchFamily="34" charset="-120"/>
-              </a:rPr>
-              <a:t>a solução que a pessoa já imaginou</a:t>
-            </a:r>
-            <a:endParaRPr lang="en-US" sz="3200" dirty="0"/>
-          </a:p>
-        </p:txBody>
-      </p:sp>
-      <p:sp>
-        <p:nvSpPr>
-          <p:cNvPr id="4" name="Text 2"/>
-          <p:cNvSpPr/>
-          <p:nvPr/>
-        </p:nvSpPr>
-        <p:spPr>
-          <a:xfrm>
-            <a:off x="658368" y="3310128"/>
-            <a:ext cx="9326880" cy="1463040"/>
-          </a:xfrm>
-          <a:prstGeom prst="rect">
-            <a:avLst/>
-          </a:prstGeom>
-          <a:noFill/>
-          <a:ln/>
-        </p:spPr>
-        <p:txBody>
-          <a:bodyPr wrap="square" lIns="0" tIns="0" rIns="0" bIns="0" rtlCol="0" anchor="t"/>
-          <a:lstStyle/>
-          <a:p>
-            <a:pPr indent="0" marL="0">
-              <a:lnSpc>
-                <a:spcPts val="2200"/>
-              </a:lnSpc>
-              <a:buNone/>
-            </a:pPr>
-            <a:r>
-              <a:rPr lang="en-US" sz="1500" dirty="0">
-                <a:solidFill>
-                  <a:srgbClr val="E7DCEF"/>
-                </a:solidFill>
-                <a:latin typeface="Arial" pitchFamily="34" charset="0"/>
-                <a:ea typeface="Arial" pitchFamily="34" charset="-122"/>
-                <a:cs typeface="Arial" pitchFamily="34" charset="-120"/>
-              </a:rPr>
-              <a:t>Ninguém responde com o processo. Responde com “queria um bot que respondesse os chamados”. Aí você automatiza a imaginação de alguém, não o trabalho que existe.
-</a:t>
-            </a:r>
-            <a:pPr indent="0" marL="0">
-              <a:lnSpc>
-                <a:spcPts val="2200"/>
-              </a:lnSpc>
-              <a:buNone/>
-            </a:pPr>
-            <a:r>
-              <a:rPr lang="en-US" sz="1500" b="1" dirty="0">
-                <a:solidFill>
-                  <a:srgbClr val="FFFFFF"/>
-                </a:solidFill>
-                <a:latin typeface="Arial" pitchFamily="34" charset="0"/>
-                <a:ea typeface="Arial" pitchFamily="34" charset="-122"/>
-                <a:cs typeface="Arial" pitchFamily="34" charset="-120"/>
-              </a:rPr>
-              <a:t>A pergunta que funciona é outra: “me conta o que você fez ontem, na ordem.”</a:t>
-            </a:r>
-            <a:endParaRPr lang="en-US" sz="1500" dirty="0"/>
-          </a:p>
-        </p:txBody>
-      </p:sp>
-      <p:sp>
-        <p:nvSpPr>
-          <p:cNvPr id="5" name="Text 3"/>
-          <p:cNvSpPr/>
-          <p:nvPr/>
-        </p:nvSpPr>
-        <p:spPr>
-          <a:xfrm>
-            <a:off x="658368" y="5623560"/>
-            <a:ext cx="10881360" cy="457200"/>
+              <a:t>“Me conta o que você fez ontem, na ordem.”</a:t>
+            </a:r>
+            <a:endParaRPr lang="en-US" sz="1900" dirty="0"/>
+          </a:p>
+        </p:txBody>
+      </p:sp>
+      <p:sp>
+        <p:nvSpPr>
+          <p:cNvPr id="11" name="Text 9"/>
+          <p:cNvSpPr/>
+          <p:nvPr/>
+        </p:nvSpPr>
+        <p:spPr>
+          <a:xfrm>
+            <a:off x="658368" y="5715000"/>
+            <a:ext cx="10881360" cy="411480"/>
           </a:xfrm>
           <a:prstGeom prst="rect">
             <a:avLst/>
@@ -10592,7 +10763,7 @@
         </p:nvSpPr>
         <p:spPr>
           <a:xfrm>
-            <a:off x="658368" y="1746504"/>
+            <a:off x="658368" y="1700784"/>
             <a:ext cx="10874959" cy="9144"/>
           </a:xfrm>
           <a:prstGeom prst="rect">
@@ -10617,7 +10788,7 @@
         </p:nvSpPr>
         <p:spPr>
           <a:xfrm>
-            <a:off x="768096" y="1837944"/>
+            <a:off x="768096" y="1792224"/>
             <a:ext cx="384048" cy="256032"/>
           </a:xfrm>
           <a:prstGeom prst="rect">
@@ -10656,8 +10827,8 @@
         </p:nvSpPr>
         <p:spPr>
           <a:xfrm>
-            <a:off x="1225296" y="1819656"/>
-            <a:ext cx="4480560" cy="365760"/>
+            <a:off x="1225296" y="1810512"/>
+            <a:ext cx="3840480" cy="347472"/>
           </a:xfrm>
           <a:prstGeom prst="rect">
             <a:avLst/>
@@ -10698,8 +10869,8 @@
         </p:nvSpPr>
         <p:spPr>
           <a:xfrm>
-            <a:off x="5852160" y="1819656"/>
-            <a:ext cx="5623560" cy="402336"/>
+            <a:off x="5184648" y="1810512"/>
+            <a:ext cx="6263640" cy="347472"/>
           </a:xfrm>
           <a:prstGeom prst="rect">
             <a:avLst/>
@@ -10726,7 +10897,7 @@
                 <a:ea typeface="Arial" pitchFamily="34" charset="-122"/>
                 <a:cs typeface="Arial" pitchFamily="34" charset="-120"/>
               </a:rPr>
-              <a:t>Dá as etapas </a:t>
+              <a:t>As etapas </a:t>
             </a:r>
             <a:pPr indent="0" marL="0">
               <a:lnSpc>
@@ -10760,7 +10931,7 @@
                 <a:ea typeface="Arial" pitchFamily="34" charset="-122"/>
                 <a:cs typeface="Arial" pitchFamily="34" charset="-120"/>
               </a:rPr>
-              <a:t>. A versão do gestor é a oficial; esta é a que acontece.</a:t>
+              <a:t> — não a versão oficial do gestor.</a:t>
             </a:r>
             <a:endParaRPr lang="en-US" sz="1150" dirty="0"/>
           </a:p>
@@ -10774,12 +10945,12 @@
         </p:nvSpPr>
         <p:spPr>
           <a:xfrm>
-            <a:off x="658368" y="2258568"/>
-            <a:ext cx="10874959" cy="512064"/>
+            <a:off x="658368" y="2235708"/>
+            <a:ext cx="10874959" cy="534924"/>
           </a:xfrm>
           <a:prstGeom prst="roundRect">
             <a:avLst>
-              <a:gd name="adj" fmla="val 10714"/>
+              <a:gd name="adj" fmla="val 10256"/>
             </a:avLst>
           </a:prstGeom>
           <a:solidFill>
@@ -10801,7 +10972,7 @@
         </p:nvSpPr>
         <p:spPr>
           <a:xfrm>
-            <a:off x="768096" y="2350008"/>
+            <a:off x="768096" y="2327148"/>
             <a:ext cx="384048" cy="256032"/>
           </a:xfrm>
           <a:prstGeom prst="rect">
@@ -10840,8 +11011,8 @@
         </p:nvSpPr>
         <p:spPr>
           <a:xfrm>
-            <a:off x="1225296" y="2331720"/>
-            <a:ext cx="4480560" cy="365760"/>
+            <a:off x="1225296" y="2345436"/>
+            <a:ext cx="3840480" cy="347472"/>
           </a:xfrm>
           <a:prstGeom prst="rect">
             <a:avLst/>
@@ -10882,8 +11053,8 @@
         </p:nvSpPr>
         <p:spPr>
           <a:xfrm>
-            <a:off x="5852160" y="2331720"/>
-            <a:ext cx="5623560" cy="402336"/>
+            <a:off x="5184648" y="2345436"/>
+            <a:ext cx="6263640" cy="347472"/>
           </a:xfrm>
           <a:prstGeom prst="rect">
             <a:avLst/>
@@ -10944,7 +11115,7 @@
                 <a:ea typeface="Arial" pitchFamily="34" charset="-122"/>
                 <a:cs typeface="Arial" pitchFamily="34" charset="-120"/>
               </a:rPr>
-              <a:t> — uma decisão. E quase sempre vem com a regra junto.</a:t>
+              <a:t>. E vem com a regra junto.</a:t>
             </a:r>
             <a:endParaRPr lang="en-US" sz="1150" dirty="0"/>
           </a:p>
@@ -10959,11 +11130,11 @@
         <p:spPr>
           <a:xfrm>
             <a:off x="658368" y="2770632"/>
-            <a:ext cx="10874959" cy="512064"/>
+            <a:ext cx="10874959" cy="534924"/>
           </a:xfrm>
           <a:prstGeom prst="roundRect">
             <a:avLst>
-              <a:gd name="adj" fmla="val 10714"/>
+              <a:gd name="adj" fmla="val 10256"/>
             </a:avLst>
           </a:prstGeom>
           <a:solidFill>
@@ -11024,8 +11195,8 @@
         </p:nvSpPr>
         <p:spPr>
           <a:xfrm>
-            <a:off x="1225296" y="2843784"/>
-            <a:ext cx="4480560" cy="365760"/>
+            <a:off x="1225296" y="2880360"/>
+            <a:ext cx="3840480" cy="347472"/>
           </a:xfrm>
           <a:prstGeom prst="rect">
             <a:avLst/>
@@ -11066,8 +11237,8 @@
         </p:nvSpPr>
         <p:spPr>
           <a:xfrm>
-            <a:off x="5852160" y="2843784"/>
-            <a:ext cx="5623560" cy="402336"/>
+            <a:off x="5184648" y="2880360"/>
+            <a:ext cx="6263640" cy="347472"/>
           </a:xfrm>
           <a:prstGeom prst="rect">
             <a:avLst/>
@@ -11094,7 +11265,7 @@
                 <a:ea typeface="Arial" pitchFamily="34" charset="-122"/>
                 <a:cs typeface="Arial" pitchFamily="34" charset="-120"/>
               </a:rPr>
-              <a:t>Digitação pura. É a </a:t>
+              <a:t>Digitação pura. </a:t>
             </a:r>
             <a:pPr indent="0" marL="0">
               <a:lnSpc>
@@ -11111,24 +11282,7 @@
                 <a:ea typeface="Arial" pitchFamily="34" charset="-122"/>
                 <a:cs typeface="Arial" pitchFamily="34" charset="-120"/>
               </a:rPr>
-              <a:t>primeira caixa que vira script</a:t>
-            </a:r>
-            <a:pPr indent="0" marL="0">
-              <a:lnSpc>
-                <a:spcPts val="1500"/>
-              </a:lnSpc>
-              <a:buNone/>
-            </a:pPr>
-            <a:r>
-              <a:rPr lang="en-US" sz="1150" dirty="0">
-                <a:solidFill>
-                  <a:srgbClr val="4A5578"/>
-                </a:solidFill>
-                <a:latin typeface="Arial" pitchFamily="34" charset="0"/>
-                <a:ea typeface="Arial" pitchFamily="34" charset="-122"/>
-                <a:cs typeface="Arial" pitchFamily="34" charset="-120"/>
-              </a:rPr>
-              <a:t> — sem IA nenhuma.</a:t>
+              <a:t>A primeira caixa que vira script.</a:t>
             </a:r>
             <a:endParaRPr lang="en-US" sz="1150" dirty="0"/>
           </a:p>
@@ -11142,7 +11296,7 @@
         </p:nvSpPr>
         <p:spPr>
           <a:xfrm>
-            <a:off x="658368" y="3282696"/>
+            <a:off x="658368" y="3305556"/>
             <a:ext cx="10874959" cy="9144"/>
           </a:xfrm>
           <a:prstGeom prst="rect">
@@ -11167,7 +11321,7 @@
         </p:nvSpPr>
         <p:spPr>
           <a:xfrm>
-            <a:off x="768096" y="3374136"/>
+            <a:off x="768096" y="3396996"/>
             <a:ext cx="384048" cy="256032"/>
           </a:xfrm>
           <a:prstGeom prst="rect">
@@ -11206,8 +11360,8 @@
         </p:nvSpPr>
         <p:spPr>
           <a:xfrm>
-            <a:off x="1225296" y="3355848"/>
-            <a:ext cx="4480560" cy="365760"/>
+            <a:off x="1225296" y="3415284"/>
+            <a:ext cx="3840480" cy="347472"/>
           </a:xfrm>
           <a:prstGeom prst="rect">
             <a:avLst/>
@@ -11248,8 +11402,8 @@
         </p:nvSpPr>
         <p:spPr>
           <a:xfrm>
-            <a:off x="5852160" y="3355848"/>
-            <a:ext cx="5623560" cy="402336"/>
+            <a:off x="5184648" y="3415284"/>
+            <a:ext cx="6263640" cy="347472"/>
           </a:xfrm>
           <a:prstGeom prst="rect">
             <a:avLst/>
@@ -11276,7 +11430,7 @@
                 <a:ea typeface="Arial" pitchFamily="34" charset="-122"/>
                 <a:cs typeface="Arial" pitchFamily="34" charset="-120"/>
               </a:rPr>
-              <a:t>Se não houver resposta, </a:t>
+              <a:t>Sem resposta aqui, </a:t>
             </a:r>
             <a:pPr indent="0" marL="0">
               <a:lnSpc>
@@ -11310,7 +11464,7 @@
                 <a:ea typeface="Arial" pitchFamily="34" charset="-122"/>
                 <a:cs typeface="Arial" pitchFamily="34" charset="-120"/>
               </a:rPr>
-              <a:t>: você não teria como saber que quebrou.</a:t>
+              <a:t>.</a:t>
             </a:r>
             <a:endParaRPr lang="en-US" sz="1150" dirty="0"/>
           </a:p>
@@ -11324,7 +11478,7 @@
         </p:nvSpPr>
         <p:spPr>
           <a:xfrm>
-            <a:off x="658368" y="3794760"/>
+            <a:off x="658368" y="3840480"/>
             <a:ext cx="10874959" cy="9144"/>
           </a:xfrm>
           <a:prstGeom prst="rect">
@@ -11349,7 +11503,7 @@
         </p:nvSpPr>
         <p:spPr>
           <a:xfrm>
-            <a:off x="768096" y="3886200"/>
+            <a:off x="768096" y="3931920"/>
             <a:ext cx="384048" cy="256032"/>
           </a:xfrm>
           <a:prstGeom prst="rect">
@@ -11388,8 +11542,8 @@
         </p:nvSpPr>
         <p:spPr>
           <a:xfrm>
-            <a:off x="1225296" y="3867912"/>
-            <a:ext cx="4480560" cy="365760"/>
+            <a:off x="1225296" y="3950208"/>
+            <a:ext cx="3840480" cy="347472"/>
           </a:xfrm>
           <a:prstGeom prst="rect">
             <a:avLst/>
@@ -11430,8 +11584,8 @@
         </p:nvSpPr>
         <p:spPr>
           <a:xfrm>
-            <a:off x="5852160" y="3867912"/>
-            <a:ext cx="5623560" cy="402336"/>
+            <a:off x="5184648" y="3950208"/>
+            <a:ext cx="6263640" cy="347472"/>
           </a:xfrm>
           <a:prstGeom prst="rect">
             <a:avLst/>
@@ -11458,7 +11612,7 @@
                 <a:ea typeface="Arial" pitchFamily="34" charset="-122"/>
                 <a:cs typeface="Arial" pitchFamily="34" charset="-120"/>
               </a:rPr>
-              <a:t>As exceções. Anote as frases exatas — viram os </a:t>
+              <a:t>As exceções. Viram os </a:t>
             </a:r>
             <a:pPr indent="0" marL="0">
               <a:lnSpc>
@@ -11506,7 +11660,7 @@
         </p:nvSpPr>
         <p:spPr>
           <a:xfrm>
-            <a:off x="658368" y="4306824"/>
+            <a:off x="658368" y="4375404"/>
             <a:ext cx="10874959" cy="9144"/>
           </a:xfrm>
           <a:prstGeom prst="rect">
@@ -11531,7 +11685,7 @@
         </p:nvSpPr>
         <p:spPr>
           <a:xfrm>
-            <a:off x="768096" y="4398264"/>
+            <a:off x="768096" y="4466844"/>
             <a:ext cx="384048" cy="256032"/>
           </a:xfrm>
           <a:prstGeom prst="rect">
@@ -11570,8 +11724,8 @@
         </p:nvSpPr>
         <p:spPr>
           <a:xfrm>
-            <a:off x="1225296" y="4379976"/>
-            <a:ext cx="4480560" cy="365760"/>
+            <a:off x="1225296" y="4485132"/>
+            <a:ext cx="3840480" cy="347472"/>
           </a:xfrm>
           <a:prstGeom prst="rect">
             <a:avLst/>
@@ -11612,8 +11766,8 @@
         </p:nvSpPr>
         <p:spPr>
           <a:xfrm>
-            <a:off x="5852160" y="4379976"/>
-            <a:ext cx="5623560" cy="402336"/>
+            <a:off x="5184648" y="4485132"/>
+            <a:ext cx="6263640" cy="347472"/>
           </a:xfrm>
           <a:prstGeom prst="rect">
             <a:avLst/>
@@ -11640,7 +11794,7 @@
                 <a:ea typeface="Arial" pitchFamily="34" charset="-122"/>
                 <a:cs typeface="Arial" pitchFamily="34" charset="-120"/>
               </a:rPr>
-              <a:t>Volume. Sem ele não dá pra priorizar: </a:t>
+              <a:t>Frequência. </a:t>
             </a:r>
             <a:pPr indent="0" marL="0">
               <a:lnSpc>
@@ -11657,24 +11811,7 @@
                 <a:ea typeface="Arial" pitchFamily="34" charset="-122"/>
                 <a:cs typeface="Arial" pitchFamily="34" charset="-120"/>
               </a:rPr>
-              <a:t>etapa rara não paga automação</a:t>
-            </a:r>
-            <a:pPr indent="0" marL="0">
-              <a:lnSpc>
-                <a:spcPts val="1500"/>
-              </a:lnSpc>
-              <a:buNone/>
-            </a:pPr>
-            <a:r>
-              <a:rPr lang="en-US" sz="1150" dirty="0">
-                <a:solidFill>
-                  <a:srgbClr val="4A5578"/>
-                </a:solidFill>
-                <a:latin typeface="Arial" pitchFamily="34" charset="0"/>
-                <a:ea typeface="Arial" pitchFamily="34" charset="-122"/>
-                <a:cs typeface="Arial" pitchFamily="34" charset="-120"/>
-              </a:rPr>
-              <a:t>.</a:t>
+              <a:t>Etapa rara não paga automação.</a:t>
             </a:r>
             <a:endParaRPr lang="en-US" sz="1150" dirty="0"/>
           </a:p>
@@ -11688,7 +11825,7 @@
         </p:nvSpPr>
         <p:spPr>
           <a:xfrm>
-            <a:off x="658368" y="4818888"/>
+            <a:off x="658368" y="4910328"/>
             <a:ext cx="10874959" cy="9144"/>
           </a:xfrm>
           <a:prstGeom prst="rect">
@@ -11713,7 +11850,7 @@
         </p:nvSpPr>
         <p:spPr>
           <a:xfrm>
-            <a:off x="768096" y="4910328"/>
+            <a:off x="768096" y="5001768"/>
             <a:ext cx="384048" cy="256032"/>
           </a:xfrm>
           <a:prstGeom prst="rect">
@@ -11752,8 +11889,8 @@
         </p:nvSpPr>
         <p:spPr>
           <a:xfrm>
-            <a:off x="1225296" y="4892040"/>
-            <a:ext cx="4480560" cy="365760"/>
+            <a:off x="1225296" y="5020056"/>
+            <a:ext cx="3840480" cy="347472"/>
           </a:xfrm>
           <a:prstGeom prst="rect">
             <a:avLst/>
@@ -11794,8 +11931,8 @@
         </p:nvSpPr>
         <p:spPr>
           <a:xfrm>
-            <a:off x="5852160" y="4892040"/>
-            <a:ext cx="5623560" cy="402336"/>
+            <a:off x="5184648" y="5020056"/>
+            <a:ext cx="6263640" cy="347472"/>
           </a:xfrm>
           <a:prstGeom prst="rect">
             <a:avLst/>
@@ -11822,7 +11959,7 @@
                 <a:ea typeface="Arial" pitchFamily="34" charset="-122"/>
                 <a:cs typeface="Arial" pitchFamily="34" charset="-120"/>
               </a:rPr>
-              <a:t>Custo do erro. É o número que decide se a etapa </a:t>
+              <a:t>Custo do erro. Decide se a etapa </a:t>
             </a:r>
             <a:pPr indent="0" marL="0">
               <a:lnSpc>
@@ -11870,12 +12007,12 @@
         </p:nvSpPr>
         <p:spPr>
           <a:xfrm>
-            <a:off x="658368" y="5468112"/>
-            <a:ext cx="10874959" cy="822960"/>
+            <a:off x="658368" y="5559552"/>
+            <a:ext cx="10874959" cy="603504"/>
           </a:xfrm>
           <a:prstGeom prst="roundRect">
             <a:avLst>
-              <a:gd name="adj" fmla="val 11111"/>
+              <a:gd name="adj" fmla="val 15152"/>
             </a:avLst>
           </a:prstGeom>
           <a:solidFill>
@@ -11897,8 +12034,8 @@
         </p:nvSpPr>
         <p:spPr>
           <a:xfrm>
-            <a:off x="658368" y="5468112"/>
-            <a:ext cx="45720" cy="822960"/>
+            <a:off x="658368" y="5559552"/>
+            <a:ext cx="45720" cy="603504"/>
           </a:xfrm>
           <a:prstGeom prst="rect">
             <a:avLst/>
@@ -11922,7 +12059,7 @@
         </p:nvSpPr>
         <p:spPr>
           <a:xfrm>
-            <a:off x="914400" y="5559552"/>
+            <a:off x="914400" y="5650992"/>
             <a:ext cx="7315200" cy="201168"/>
           </a:xfrm>
           <a:prstGeom prst="rect">
@@ -11961,8 +12098,8 @@
         </p:nvSpPr>
         <p:spPr>
           <a:xfrm>
-            <a:off x="914400" y="5779008"/>
-            <a:ext cx="10362895" cy="438912"/>
+            <a:off x="914400" y="5870448"/>
+            <a:ext cx="10362895" cy="219456"/>
           </a:xfrm>
           <a:prstGeom prst="rect">
             <a:avLst/>
@@ -12023,7 +12160,7 @@
                 <a:ea typeface="Arial" pitchFamily="34" charset="-122"/>
                 <a:cs typeface="Arial" pitchFamily="34" charset="-120"/>
               </a:rPr>
-              <a:t> te entrega os losangos e a </a:t>
+              <a:t> te entrega os losangos; a </a:t>
             </a:r>
             <a:pPr indent="0" marL="0">
               <a:lnSpc>
@@ -12057,7 +12194,7 @@
                 <a:ea typeface="Arial" pitchFamily="34" charset="-122"/>
                 <a:cs typeface="Arial" pitchFamily="34" charset="-120"/>
               </a:rPr>
-              <a:t> te entrega as caixas que viram script. As outras cinco servem pra você saber se vale a pena mexer. Grave a conversa (com permissão) e desenhe em cima da transcrição — não da memória.</a:t>
+              <a:t>, as caixas que viram script. Grave a conversa e desenhe em cima da transcrição — não da memória.</a:t>
             </a:r>
             <a:endParaRPr lang="en-US" sz="1200" dirty="0"/>
           </a:p>
@@ -14305,12 +14442,12 @@
         </p:nvSpPr>
         <p:spPr>
           <a:xfrm>
-            <a:off x="7056120" y="1773936"/>
-            <a:ext cx="1402080" cy="304800"/>
+            <a:off x="7279767" y="1774393"/>
+            <a:ext cx="1419606" cy="308610"/>
           </a:xfrm>
           <a:prstGeom prst="roundRect">
             <a:avLst>
-              <a:gd name="adj" fmla="val 150000"/>
+              <a:gd name="adj" fmla="val 148148"/>
             </a:avLst>
           </a:prstGeom>
           <a:solidFill>
@@ -14328,12 +14465,12 @@
           <a:p>
             <a:pPr algn="ctr" indent="0" marL="0">
               <a:lnSpc>
-                <a:spcPts val="1080"/>
-              </a:lnSpc>
-              <a:buNone/>
-            </a:pPr>
-            <a:r>
-              <a:rPr lang="en-US" sz="864" b="1" dirty="0">
+                <a:spcPts val="1093"/>
+              </a:lnSpc>
+              <a:buNone/>
+            </a:pPr>
+            <a:r>
+              <a:rPr lang="en-US" sz="875" b="1" dirty="0">
                 <a:solidFill>
                   <a:srgbClr val="6D2077"/>
                 </a:solidFill>
@@ -14343,7 +14480,7 @@
               </a:rPr>
               <a:t>Chamado chega</a:t>
             </a:r>
-            <a:endParaRPr lang="en-US" sz="864" dirty="0"/>
+            <a:endParaRPr lang="en-US" sz="875" dirty="0"/>
           </a:p>
         </p:txBody>
       </p:sp>
@@ -14355,12 +14492,12 @@
         </p:nvSpPr>
         <p:spPr>
           <a:xfrm>
-            <a:off x="7056120" y="2273808"/>
-            <a:ext cx="1402080" cy="316992"/>
+            <a:off x="7279767" y="2280514"/>
+            <a:ext cx="1419606" cy="320954"/>
           </a:xfrm>
           <a:prstGeom prst="roundRect">
             <a:avLst>
-              <a:gd name="adj" fmla="val 25962"/>
+              <a:gd name="adj" fmla="val 25641"/>
             </a:avLst>
           </a:prstGeom>
           <a:solidFill>
@@ -14378,12 +14515,12 @@
           <a:p>
             <a:pPr algn="ctr" indent="0" marL="0">
               <a:lnSpc>
-                <a:spcPts val="1140"/>
-              </a:lnSpc>
-              <a:buNone/>
-            </a:pPr>
-            <a:r>
-              <a:rPr lang="en-US" sz="912" dirty="0">
+                <a:spcPts val="1154"/>
+              </a:lnSpc>
+              <a:buNone/>
+            </a:pPr>
+            <a:r>
+              <a:rPr lang="en-US" sz="923" dirty="0">
                 <a:solidFill>
                   <a:srgbClr val="16224E"/>
                 </a:solidFill>
@@ -14393,7 +14530,7 @@
               </a:rPr>
               <a:t>Registrar chamado</a:t>
             </a:r>
-            <a:endParaRPr lang="en-US" sz="912" dirty="0"/>
+            <a:endParaRPr lang="en-US" sz="923" dirty="0"/>
           </a:p>
         </p:txBody>
       </p:sp>
@@ -14405,12 +14542,12 @@
         </p:nvSpPr>
         <p:spPr>
           <a:xfrm>
-            <a:off x="7056120" y="2785872"/>
-            <a:ext cx="1402080" cy="316992"/>
+            <a:off x="7279767" y="2798978"/>
+            <a:ext cx="1419606" cy="320954"/>
           </a:xfrm>
           <a:prstGeom prst="roundRect">
             <a:avLst>
-              <a:gd name="adj" fmla="val 25962"/>
+              <a:gd name="adj" fmla="val 25641"/>
             </a:avLst>
           </a:prstGeom>
           <a:solidFill>
@@ -14428,12 +14565,12 @@
           <a:p>
             <a:pPr algn="ctr" indent="0" marL="0">
               <a:lnSpc>
-                <a:spcPts val="1140"/>
-              </a:lnSpc>
-              <a:buNone/>
-            </a:pPr>
-            <a:r>
-              <a:rPr lang="en-US" sz="912" dirty="0">
+                <a:spcPts val="1154"/>
+              </a:lnSpc>
+              <a:buNone/>
+            </a:pPr>
+            <a:r>
+              <a:rPr lang="en-US" sz="923" dirty="0">
                 <a:solidFill>
                   <a:srgbClr val="16224E"/>
                 </a:solidFill>
@@ -14443,7 +14580,7 @@
               </a:rPr>
               <a:t>Classificar assunto</a:t>
             </a:r>
-            <a:endParaRPr lang="en-US" sz="912" dirty="0"/>
+            <a:endParaRPr lang="en-US" sz="923" dirty="0"/>
           </a:p>
         </p:txBody>
       </p:sp>
@@ -14455,12 +14592,12 @@
         </p:nvSpPr>
         <p:spPr>
           <a:xfrm>
-            <a:off x="7056120" y="3297936"/>
-            <a:ext cx="1402080" cy="316992"/>
+            <a:off x="7279767" y="3317443"/>
+            <a:ext cx="1419606" cy="320954"/>
           </a:xfrm>
           <a:prstGeom prst="roundRect">
             <a:avLst>
-              <a:gd name="adj" fmla="val 25962"/>
+              <a:gd name="adj" fmla="val 25641"/>
             </a:avLst>
           </a:prstGeom>
           <a:solidFill>
@@ -14478,12 +14615,12 @@
           <a:p>
             <a:pPr algn="ctr" indent="0" marL="0">
               <a:lnSpc>
-                <a:spcPts val="1140"/>
-              </a:lnSpc>
-              <a:buNone/>
-            </a:pPr>
-            <a:r>
-              <a:rPr lang="en-US" sz="912" dirty="0">
+                <a:spcPts val="1154"/>
+              </a:lnSpc>
+              <a:buNone/>
+            </a:pPr>
+            <a:r>
+              <a:rPr lang="en-US" sz="923" dirty="0">
                 <a:solidFill>
                   <a:srgbClr val="16224E"/>
                 </a:solidFill>
@@ -14493,7 +14630,7 @@
               </a:rPr>
               <a:t>Redigir resposta</a:t>
             </a:r>
-            <a:endParaRPr lang="en-US" sz="912" dirty="0"/>
+            <a:endParaRPr lang="en-US" sz="923" dirty="0"/>
           </a:p>
         </p:txBody>
       </p:sp>
@@ -14505,8 +14642,8 @@
         </p:nvSpPr>
         <p:spPr>
           <a:xfrm>
-            <a:off x="7056120" y="3834384"/>
-            <a:ext cx="1402080" cy="585216"/>
+            <a:off x="7279767" y="3860597"/>
+            <a:ext cx="1419606" cy="592531"/>
           </a:xfrm>
           <a:prstGeom prst="diamond">
             <a:avLst/>
@@ -14526,12 +14663,12 @@
           <a:p>
             <a:pPr algn="ctr" indent="0" marL="0">
               <a:lnSpc>
-                <a:spcPts val="1020"/>
-              </a:lnSpc>
-              <a:buNone/>
-            </a:pPr>
-            <a:r>
-              <a:rPr lang="en-US" sz="816" dirty="0">
+                <a:spcPts val="1033"/>
+              </a:lnSpc>
+              <a:buNone/>
+            </a:pPr>
+            <a:r>
+              <a:rPr lang="en-US" sz="826" dirty="0">
                 <a:solidFill>
                   <a:srgbClr val="16224E"/>
                 </a:solidFill>
@@ -14541,17 +14678,17 @@
               </a:rPr>
               <a:t>Desconto</a:t>
             </a:r>
-            <a:endParaRPr lang="en-US" sz="816" dirty="0"/>
+            <a:endParaRPr lang="en-US" sz="826" dirty="0"/>
           </a:p>
           <a:p>
             <a:pPr algn="ctr" indent="0" marL="0">
               <a:lnSpc>
-                <a:spcPts val="1020"/>
-              </a:lnSpc>
-              <a:buNone/>
-            </a:pPr>
-            <a:r>
-              <a:rPr lang="en-US" sz="816" dirty="0">
+                <a:spcPts val="1033"/>
+              </a:lnSpc>
+              <a:buNone/>
+            </a:pPr>
+            <a:r>
+              <a:rPr lang="en-US" sz="826" dirty="0">
                 <a:solidFill>
                   <a:srgbClr val="16224E"/>
                 </a:solidFill>
@@ -14561,7 +14698,7 @@
               </a:rPr>
               <a:t>acima de 10%?</a:t>
             </a:r>
-            <a:endParaRPr lang="en-US" sz="816" dirty="0"/>
+            <a:endParaRPr lang="en-US" sz="826" dirty="0"/>
           </a:p>
         </p:txBody>
       </p:sp>
@@ -14573,12 +14710,12 @@
         </p:nvSpPr>
         <p:spPr>
           <a:xfrm>
-            <a:off x="8763000" y="3968496"/>
-            <a:ext cx="1280160" cy="316992"/>
+            <a:off x="9007983" y="3996385"/>
+            <a:ext cx="1296162" cy="320954"/>
           </a:xfrm>
           <a:prstGeom prst="roundRect">
             <a:avLst>
-              <a:gd name="adj" fmla="val 25962"/>
+              <a:gd name="adj" fmla="val 25641"/>
             </a:avLst>
           </a:prstGeom>
           <a:solidFill>
@@ -14596,12 +14733,12 @@
           <a:p>
             <a:pPr algn="ctr" indent="0" marL="0">
               <a:lnSpc>
-                <a:spcPts val="1140"/>
-              </a:lnSpc>
-              <a:buNone/>
-            </a:pPr>
-            <a:r>
-              <a:rPr lang="en-US" sz="912" dirty="0">
+                <a:spcPts val="1154"/>
+              </a:lnSpc>
+              <a:buNone/>
+            </a:pPr>
+            <a:r>
+              <a:rPr lang="en-US" sz="923" dirty="0">
                 <a:solidFill>
                   <a:srgbClr val="16224E"/>
                 </a:solidFill>
@@ -14611,7 +14748,7 @@
               </a:rPr>
               <a:t>Gestor aprova</a:t>
             </a:r>
-            <a:endParaRPr lang="en-US" sz="912" dirty="0"/>
+            <a:endParaRPr lang="en-US" sz="923" dirty="0"/>
           </a:p>
         </p:txBody>
       </p:sp>
@@ -14623,12 +14760,12 @@
         </p:nvSpPr>
         <p:spPr>
           <a:xfrm>
-            <a:off x="7056120" y="4626864"/>
-            <a:ext cx="1402080" cy="316992"/>
+            <a:off x="7279767" y="4662983"/>
+            <a:ext cx="1419606" cy="320954"/>
           </a:xfrm>
           <a:prstGeom prst="roundRect">
             <a:avLst>
-              <a:gd name="adj" fmla="val 25962"/>
+              <a:gd name="adj" fmla="val 25641"/>
             </a:avLst>
           </a:prstGeom>
           <a:solidFill>
@@ -14646,12 +14783,12 @@
           <a:p>
             <a:pPr algn="ctr" indent="0" marL="0">
               <a:lnSpc>
-                <a:spcPts val="1140"/>
-              </a:lnSpc>
-              <a:buNone/>
-            </a:pPr>
-            <a:r>
-              <a:rPr lang="en-US" sz="912" dirty="0">
+                <a:spcPts val="1154"/>
+              </a:lnSpc>
+              <a:buNone/>
+            </a:pPr>
+            <a:r>
+              <a:rPr lang="en-US" sz="923" dirty="0">
                 <a:solidFill>
                   <a:srgbClr val="16224E"/>
                 </a:solidFill>
@@ -14661,7 +14798,7 @@
               </a:rPr>
               <a:t>Enviar resposta</a:t>
             </a:r>
-            <a:endParaRPr lang="en-US" sz="912" dirty="0"/>
+            <a:endParaRPr lang="en-US" sz="923" dirty="0"/>
           </a:p>
         </p:txBody>
       </p:sp>
@@ -14673,12 +14810,12 @@
         </p:nvSpPr>
         <p:spPr>
           <a:xfrm>
-            <a:off x="9555480" y="4626864"/>
-            <a:ext cx="609600" cy="316992"/>
+            <a:off x="9810369" y="4662983"/>
+            <a:ext cx="617220" cy="320954"/>
           </a:xfrm>
           <a:prstGeom prst="roundRect">
             <a:avLst>
-              <a:gd name="adj" fmla="val 144231"/>
+              <a:gd name="adj" fmla="val 142450"/>
             </a:avLst>
           </a:prstGeom>
           <a:solidFill>
@@ -14696,12 +14833,12 @@
           <a:p>
             <a:pPr algn="ctr" indent="0" marL="0">
               <a:lnSpc>
-                <a:spcPts val="1080"/>
-              </a:lnSpc>
-              <a:buNone/>
-            </a:pPr>
-            <a:r>
-              <a:rPr lang="en-US" sz="864" b="1" dirty="0">
+                <a:spcPts val="1093"/>
+              </a:lnSpc>
+              <a:buNone/>
+            </a:pPr>
+            <a:r>
+              <a:rPr lang="en-US" sz="875" b="1" dirty="0">
                 <a:solidFill>
                   <a:srgbClr val="6D2077"/>
                 </a:solidFill>
@@ -14711,7 +14848,7 @@
               </a:rPr>
               <a:t>Fim</a:t>
             </a:r>
-            <a:endParaRPr lang="en-US" sz="864" dirty="0"/>
+            <a:endParaRPr lang="en-US" sz="875" dirty="0"/>
           </a:p>
         </p:txBody>
       </p:sp>
@@ -14723,8 +14860,8 @@
         </p:nvSpPr>
         <p:spPr>
           <a:xfrm>
-            <a:off x="7757160" y="2078736"/>
-            <a:ext cx="0" cy="158496"/>
+            <a:off x="7989570" y="2083003"/>
+            <a:ext cx="0" cy="160477"/>
           </a:xfrm>
           <a:prstGeom prst="line">
             <a:avLst/>
@@ -14747,8 +14884,8 @@
         </p:nvSpPr>
         <p:spPr>
           <a:xfrm>
-            <a:off x="7757160" y="2590800"/>
-            <a:ext cx="0" cy="158496"/>
+            <a:off x="7989570" y="2601468"/>
+            <a:ext cx="0" cy="160477"/>
           </a:xfrm>
           <a:prstGeom prst="line">
             <a:avLst/>
@@ -14771,8 +14908,8 @@
         </p:nvSpPr>
         <p:spPr>
           <a:xfrm>
-            <a:off x="7757160" y="3102864"/>
-            <a:ext cx="0" cy="158496"/>
+            <a:off x="7989570" y="3119933"/>
+            <a:ext cx="0" cy="160477"/>
           </a:xfrm>
           <a:prstGeom prst="line">
             <a:avLst/>
@@ -14795,8 +14932,8 @@
         </p:nvSpPr>
         <p:spPr>
           <a:xfrm>
-            <a:off x="7757160" y="3614928"/>
-            <a:ext cx="0" cy="182880"/>
+            <a:off x="7989570" y="3638398"/>
+            <a:ext cx="0" cy="185166"/>
           </a:xfrm>
           <a:prstGeom prst="line">
             <a:avLst/>
@@ -14819,8 +14956,8 @@
         </p:nvSpPr>
         <p:spPr>
           <a:xfrm>
-            <a:off x="8458200" y="4126992"/>
-            <a:ext cx="268224" cy="0"/>
+            <a:off x="8699373" y="4156862"/>
+            <a:ext cx="271577" cy="0"/>
           </a:xfrm>
           <a:prstGeom prst="line">
             <a:avLst/>
@@ -14843,8 +14980,8 @@
         </p:nvSpPr>
         <p:spPr>
           <a:xfrm>
-            <a:off x="7757160" y="4419600"/>
-            <a:ext cx="0" cy="170688"/>
+            <a:off x="7989570" y="4453128"/>
+            <a:ext cx="0" cy="172822"/>
           </a:xfrm>
           <a:prstGeom prst="line">
             <a:avLst/>
@@ -14867,8 +15004,8 @@
         </p:nvSpPr>
         <p:spPr>
           <a:xfrm>
-            <a:off x="9403080" y="4285488"/>
-            <a:ext cx="0" cy="195072"/>
+            <a:off x="9656064" y="4317340"/>
+            <a:ext cx="0" cy="197510"/>
           </a:xfrm>
           <a:prstGeom prst="line">
             <a:avLst/>
@@ -14890,8 +15027,8 @@
         </p:nvSpPr>
         <p:spPr>
           <a:xfrm flipH="1">
-            <a:off x="8153400" y="4480560"/>
-            <a:ext cx="1249680" cy="0"/>
+            <a:off x="8390763" y="4514850"/>
+            <a:ext cx="1265301" cy="0"/>
           </a:xfrm>
           <a:prstGeom prst="line">
             <a:avLst/>
@@ -14913,8 +15050,8 @@
         </p:nvSpPr>
         <p:spPr>
           <a:xfrm>
-            <a:off x="8153400" y="4480560"/>
-            <a:ext cx="0" cy="109728"/>
+            <a:off x="8390763" y="4514850"/>
+            <a:ext cx="0" cy="111100"/>
           </a:xfrm>
           <a:prstGeom prst="line">
             <a:avLst/>
@@ -14937,8 +15074,8 @@
         </p:nvSpPr>
         <p:spPr>
           <a:xfrm>
-            <a:off x="8458200" y="4785360"/>
-            <a:ext cx="1060704" cy="0"/>
+            <a:off x="8699373" y="4823460"/>
+            <a:ext cx="1073963" cy="0"/>
           </a:xfrm>
           <a:prstGeom prst="line">
             <a:avLst/>
@@ -14961,8 +15098,8 @@
         </p:nvSpPr>
         <p:spPr>
           <a:xfrm>
-            <a:off x="8506968" y="3962400"/>
-            <a:ext cx="243840" cy="134112"/>
+            <a:off x="8748751" y="3990213"/>
+            <a:ext cx="246888" cy="135788"/>
           </a:xfrm>
           <a:prstGeom prst="rect">
             <a:avLst/>
@@ -14976,12 +15113,12 @@
           <a:p>
             <a:pPr algn="l" indent="0" marL="0">
               <a:lnSpc>
-                <a:spcPts val="936"/>
-              </a:lnSpc>
-              <a:buNone/>
-            </a:pPr>
-            <a:r>
-              <a:rPr lang="en-US" sz="720" b="1" dirty="0">
+                <a:spcPts val="948"/>
+              </a:lnSpc>
+              <a:buNone/>
+            </a:pPr>
+            <a:r>
+              <a:rPr lang="en-US" sz="729" b="1" dirty="0">
                 <a:solidFill>
                   <a:srgbClr val="6E6684"/>
                 </a:solidFill>
@@ -14991,7 +15128,7 @@
               </a:rPr>
               <a:t>sim</a:t>
             </a:r>
-            <a:endParaRPr lang="en-US" sz="720" dirty="0"/>
+            <a:endParaRPr lang="en-US" sz="729" dirty="0"/>
           </a:p>
         </p:txBody>
       </p:sp>
@@ -15003,8 +15140,8 @@
         </p:nvSpPr>
         <p:spPr>
           <a:xfrm>
-            <a:off x="7824216" y="4437888"/>
-            <a:ext cx="243840" cy="134112"/>
+            <a:off x="8057464" y="4471645"/>
+            <a:ext cx="246888" cy="135788"/>
           </a:xfrm>
           <a:prstGeom prst="rect">
             <a:avLst/>
@@ -15018,12 +15155,12 @@
           <a:p>
             <a:pPr algn="l" indent="0" marL="0">
               <a:lnSpc>
-                <a:spcPts val="936"/>
-              </a:lnSpc>
-              <a:buNone/>
-            </a:pPr>
-            <a:r>
-              <a:rPr lang="en-US" sz="720" b="1" dirty="0">
+                <a:spcPts val="948"/>
+              </a:lnSpc>
+              <a:buNone/>
+            </a:pPr>
+            <a:r>
+              <a:rPr lang="en-US" sz="729" b="1" dirty="0">
                 <a:solidFill>
                   <a:srgbClr val="6E6684"/>
                 </a:solidFill>
@@ -15033,7 +15170,7 @@
               </a:rPr>
               <a:t>não</a:t>
             </a:r>
-            <a:endParaRPr lang="en-US" sz="720" dirty="0"/>
+            <a:endParaRPr lang="en-US" sz="729" dirty="0"/>
           </a:p>
         </p:txBody>
       </p:sp>
@@ -15045,8 +15182,8 @@
         </p:nvSpPr>
         <p:spPr>
           <a:xfrm>
-            <a:off x="7056120" y="5065776"/>
-            <a:ext cx="2011680" cy="134112"/>
+            <a:off x="7279767" y="5107381"/>
+            <a:ext cx="2036826" cy="135788"/>
           </a:xfrm>
           <a:prstGeom prst="rect">
             <a:avLst/>
@@ -15060,12 +15197,12 @@
           <a:p>
             <a:pPr algn="l" indent="0" marL="0">
               <a:lnSpc>
-                <a:spcPts val="998"/>
-              </a:lnSpc>
-              <a:buNone/>
-            </a:pPr>
-            <a:r>
-              <a:rPr lang="en-US" sz="768" b="1" dirty="0">
+                <a:spcPts val="1011"/>
+              </a:lnSpc>
+              <a:buNone/>
+            </a:pPr>
+            <a:r>
+              <a:rPr lang="en-US" sz="778" b="1" dirty="0">
                 <a:solidFill>
                   <a:srgbClr val="E80070"/>
                 </a:solidFill>
@@ -15075,7 +15212,7 @@
               </a:rPr>
               <a:t>A REGRA DO LOSANGO, ESCRITA:</a:t>
             </a:r>
-            <a:endParaRPr lang="en-US" sz="768" dirty="0"/>
+            <a:endParaRPr lang="en-US" sz="778" dirty="0"/>
           </a:p>
         </p:txBody>
       </p:sp>
@@ -15087,8 +15224,8 @@
         </p:nvSpPr>
         <p:spPr>
           <a:xfrm>
-            <a:off x="7056120" y="5212080"/>
-            <a:ext cx="2316480" cy="134112"/>
+            <a:off x="7279767" y="5255514"/>
+            <a:ext cx="2345436" cy="135788"/>
           </a:xfrm>
           <a:prstGeom prst="rect">
             <a:avLst/>
@@ -15102,12 +15239,12 @@
           <a:p>
             <a:pPr algn="l" indent="0" marL="0">
               <a:lnSpc>
-                <a:spcPts val="1061"/>
-              </a:lnSpc>
-              <a:buNone/>
-            </a:pPr>
-            <a:r>
-              <a:rPr lang="en-US" sz="816" dirty="0">
+                <a:spcPts val="1074"/>
+              </a:lnSpc>
+              <a:buNone/>
+            </a:pPr>
+            <a:r>
+              <a:rPr lang="en-US" sz="826" dirty="0">
                 <a:solidFill>
                   <a:srgbClr val="4A5578"/>
                 </a:solidFill>
@@ -15117,7 +15254,7 @@
               </a:rPr>
               <a:t>desconto &gt; 10% ou exceção contratual</a:t>
             </a:r>
-            <a:endParaRPr lang="en-US" sz="816" dirty="0"/>
+            <a:endParaRPr lang="en-US" sz="826" dirty="0"/>
           </a:p>
         </p:txBody>
       </p:sp>
@@ -15129,12 +15266,12 @@
         </p:nvSpPr>
         <p:spPr>
           <a:xfrm>
-            <a:off x="658368" y="5504688"/>
-            <a:ext cx="10874959" cy="768096"/>
+            <a:off x="658368" y="5614416"/>
+            <a:ext cx="10874959" cy="530352"/>
           </a:xfrm>
           <a:prstGeom prst="roundRect">
             <a:avLst>
-              <a:gd name="adj" fmla="val 11905"/>
+              <a:gd name="adj" fmla="val 17241"/>
             </a:avLst>
           </a:prstGeom>
           <a:solidFill>
@@ -15156,8 +15293,8 @@
         </p:nvSpPr>
         <p:spPr>
           <a:xfrm>
-            <a:off x="658368" y="5504688"/>
-            <a:ext cx="45720" cy="768096"/>
+            <a:off x="658368" y="5614416"/>
+            <a:ext cx="45720" cy="530352"/>
           </a:xfrm>
           <a:prstGeom prst="rect">
             <a:avLst/>
@@ -15181,8 +15318,8 @@
         </p:nvSpPr>
         <p:spPr>
           <a:xfrm>
-            <a:off x="914400" y="5596128"/>
-            <a:ext cx="7315200" cy="201168"/>
+            <a:off x="914400" y="5742432"/>
+            <a:ext cx="10362895" cy="274320"/>
           </a:xfrm>
           <a:prstGeom prst="rect">
             <a:avLst/>
@@ -15195,136 +15332,97 @@
           <a:lstStyle/>
           <a:p>
             <a:pPr indent="0" marL="0">
-              <a:buNone/>
-            </a:pPr>
-            <a:r>
-              <a:rPr lang="en-US" sz="950" b="1" spc="180" kern="0" dirty="0">
-                <a:solidFill>
-                  <a:srgbClr val="E80070"/>
-                </a:solidFill>
-                <a:latin typeface="Arial" pitchFamily="34" charset="0"/>
-                <a:ea typeface="Arial" pitchFamily="34" charset="-122"/>
-                <a:cs typeface="Arial" pitchFamily="34" charset="-120"/>
-              </a:rPr>
-              <a:t>O QUE ACABOU DE ACONTECER</a:t>
-            </a:r>
-            <a:endParaRPr lang="en-US" sz="950" dirty="0"/>
+              <a:lnSpc>
+                <a:spcPts val="1600"/>
+              </a:lnSpc>
+              <a:buNone/>
+            </a:pPr>
+            <a:r>
+              <a:rPr lang="en-US" sz="1200" dirty="0">
+                <a:solidFill>
+                  <a:srgbClr val="16224E"/>
+                </a:solidFill>
+                <a:latin typeface="Arial" pitchFamily="34" charset="0"/>
+                <a:ea typeface="Arial" pitchFamily="34" charset="-122"/>
+                <a:cs typeface="Arial" pitchFamily="34" charset="-120"/>
+              </a:rPr>
+              <a:t>A quinta frase entregou </a:t>
+            </a:r>
+            <a:pPr indent="0" marL="0">
+              <a:lnSpc>
+                <a:spcPts val="1600"/>
+              </a:lnSpc>
+              <a:buNone/>
+            </a:pPr>
+            <a:r>
+              <a:rPr lang="en-US" sz="1200" b="1" dirty="0">
+                <a:solidFill>
+                  <a:srgbClr val="16224E"/>
+                </a:solidFill>
+                <a:latin typeface="Arial" pitchFamily="34" charset="0"/>
+                <a:ea typeface="Arial" pitchFamily="34" charset="-122"/>
+                <a:cs typeface="Arial" pitchFamily="34" charset="-120"/>
+              </a:rPr>
+              <a:t>o losango e a regra na mesma respiração</a:t>
+            </a:r>
+            <a:pPr indent="0" marL="0">
+              <a:lnSpc>
+                <a:spcPts val="1600"/>
+              </a:lnSpc>
+              <a:buNone/>
+            </a:pPr>
+            <a:r>
+              <a:rPr lang="en-US" sz="1200" dirty="0">
+                <a:solidFill>
+                  <a:srgbClr val="16224E"/>
+                </a:solidFill>
+                <a:latin typeface="Arial" pitchFamily="34" charset="0"/>
+                <a:ea typeface="Arial" pitchFamily="34" charset="-122"/>
+                <a:cs typeface="Arial" pitchFamily="34" charset="-120"/>
+              </a:rPr>
+              <a:t>. E repare: até aqui </a:t>
+            </a:r>
+            <a:pPr indent="0" marL="0">
+              <a:lnSpc>
+                <a:spcPts val="1600"/>
+              </a:lnSpc>
+              <a:buNone/>
+            </a:pPr>
+            <a:r>
+              <a:rPr lang="en-US" sz="1200" b="1" dirty="0">
+                <a:solidFill>
+                  <a:srgbClr val="16224E"/>
+                </a:solidFill>
+                <a:latin typeface="Arial" pitchFamily="34" charset="0"/>
+                <a:ea typeface="Arial" pitchFamily="34" charset="-122"/>
+                <a:cs typeface="Arial" pitchFamily="34" charset="-120"/>
+              </a:rPr>
+              <a:t>nada foi dito sobre IA</a:t>
+            </a:r>
+            <a:pPr indent="0" marL="0">
+              <a:lnSpc>
+                <a:spcPts val="1600"/>
+              </a:lnSpc>
+              <a:buNone/>
+            </a:pPr>
+            <a:r>
+              <a:rPr lang="en-US" sz="1200" dirty="0">
+                <a:solidFill>
+                  <a:srgbClr val="16224E"/>
+                </a:solidFill>
+                <a:latin typeface="Arial" pitchFamily="34" charset="0"/>
+                <a:ea typeface="Arial" pitchFamily="34" charset="-122"/>
+                <a:cs typeface="Arial" pitchFamily="34" charset="-120"/>
+              </a:rPr>
+              <a:t>.</a:t>
+            </a:r>
+            <a:endParaRPr lang="en-US" sz="1200" dirty="0"/>
           </a:p>
         </p:txBody>
       </p:sp>
       <p:sp>
         <p:nvSpPr>
           <p:cNvPr id="50" name="Text 48"/>
-          <p:cNvSpPr/>
-          <p:nvPr/>
-        </p:nvSpPr>
-        <p:spPr>
-          <a:xfrm>
-            <a:off x="914400" y="5815584"/>
-            <a:ext cx="10362895" cy="384048"/>
-          </a:xfrm>
-          <a:prstGeom prst="rect">
-            <a:avLst/>
-          </a:prstGeom>
-          <a:noFill/>
-          <a:ln/>
-        </p:spPr>
-        <p:txBody>
-          <a:bodyPr wrap="square" lIns="0" tIns="0" rIns="0" bIns="0" rtlCol="0" anchor="t"/>
-          <a:lstStyle/>
-          <a:p>
-            <a:pPr indent="0" marL="0">
-              <a:lnSpc>
-                <a:spcPts val="1600"/>
-              </a:lnSpc>
-              <a:buNone/>
-            </a:pPr>
-            <a:r>
-              <a:rPr lang="en-US" sz="1200" dirty="0">
-                <a:solidFill>
-                  <a:srgbClr val="16224E"/>
-                </a:solidFill>
-                <a:latin typeface="Arial" pitchFamily="34" charset="0"/>
-                <a:ea typeface="Arial" pitchFamily="34" charset="-122"/>
-                <a:cs typeface="Arial" pitchFamily="34" charset="-120"/>
-              </a:rPr>
-              <a:t>A quinta frase entregou </a:t>
-            </a:r>
-            <a:pPr indent="0" marL="0">
-              <a:lnSpc>
-                <a:spcPts val="1600"/>
-              </a:lnSpc>
-              <a:buNone/>
-            </a:pPr>
-            <a:r>
-              <a:rPr lang="en-US" sz="1200" b="1" dirty="0">
-                <a:solidFill>
-                  <a:srgbClr val="16224E"/>
-                </a:solidFill>
-                <a:latin typeface="Arial" pitchFamily="34" charset="0"/>
-                <a:ea typeface="Arial" pitchFamily="34" charset="-122"/>
-                <a:cs typeface="Arial" pitchFamily="34" charset="-120"/>
-              </a:rPr>
-              <a:t>o losango e a regra na mesma respiração</a:t>
-            </a:r>
-            <a:pPr indent="0" marL="0">
-              <a:lnSpc>
-                <a:spcPts val="1600"/>
-              </a:lnSpc>
-              <a:buNone/>
-            </a:pPr>
-            <a:r>
-              <a:rPr lang="en-US" sz="1200" dirty="0">
-                <a:solidFill>
-                  <a:srgbClr val="16224E"/>
-                </a:solidFill>
-                <a:latin typeface="Arial" pitchFamily="34" charset="0"/>
-                <a:ea typeface="Arial" pitchFamily="34" charset="-122"/>
-                <a:cs typeface="Arial" pitchFamily="34" charset="-120"/>
-              </a:rPr>
-              <a:t> — é por isso que a pergunta 2 vale por três. E repare: até aqui </a:t>
-            </a:r>
-            <a:pPr indent="0" marL="0">
-              <a:lnSpc>
-                <a:spcPts val="1600"/>
-              </a:lnSpc>
-              <a:buNone/>
-            </a:pPr>
-            <a:r>
-              <a:rPr lang="en-US" sz="1200" b="1" dirty="0">
-                <a:solidFill>
-                  <a:srgbClr val="16224E"/>
-                </a:solidFill>
-                <a:latin typeface="Arial" pitchFamily="34" charset="0"/>
-                <a:ea typeface="Arial" pitchFamily="34" charset="-122"/>
-                <a:cs typeface="Arial" pitchFamily="34" charset="-120"/>
-              </a:rPr>
-              <a:t>nada foi dito sobre IA</a:t>
-            </a:r>
-            <a:pPr indent="0" marL="0">
-              <a:lnSpc>
-                <a:spcPts val="1600"/>
-              </a:lnSpc>
-              <a:buNone/>
-            </a:pPr>
-            <a:r>
-              <a:rPr lang="en-US" sz="1200" dirty="0">
-                <a:solidFill>
-                  <a:srgbClr val="16224E"/>
-                </a:solidFill>
-                <a:latin typeface="Arial" pitchFamily="34" charset="0"/>
-                <a:ea typeface="Arial" pitchFamily="34" charset="-122"/>
-                <a:cs typeface="Arial" pitchFamily="34" charset="-120"/>
-              </a:rPr>
-              <a:t>. Quem não consegue fechar as setas descobriu que tem dois processos, não um.</a:t>
-            </a:r>
-            <a:endParaRPr lang="en-US" sz="1200" dirty="0"/>
-          </a:p>
-        </p:txBody>
-      </p:sp>
-      <p:sp>
-        <p:nvSpPr>
-          <p:cNvPr id="51" name="Text 49"/>
           <p:cNvSpPr/>
           <p:nvPr/>
         </p:nvSpPr>
@@ -15363,7 +15461,7 @@
       </p:sp>
       <p:sp>
         <p:nvSpPr>
-          <p:cNvPr id="52" name="Text 50"/>
+          <p:cNvPr id="51" name="Text 49"/>
           <p:cNvSpPr/>
           <p:nvPr/>
         </p:nvSpPr>
@@ -15986,7 +16084,7 @@
                 <a:ea typeface="Courier New" pitchFamily="34" charset="-122"/>
                 <a:cs typeface="Courier New" pitchFamily="34" charset="-120"/>
               </a:rPr>
-              <a:t>Classificar 12 mil chamados/mês · extrair campo de documento · redigir a primeira versão da resposta</a:t>
+              <a:t>Classificar todo chamado que entra · extrair campo de documento · redigir a primeira versão da resposta</a:t>
             </a:r>
             <a:endParaRPr lang="en-US" sz="1050" dirty="0"/>
           </a:p>
@@ -18363,7 +18461,7 @@
         </p:nvSpPr>
         <p:spPr>
           <a:xfrm>
-            <a:off x="1199789" y="1917834"/>
+            <a:off x="1146850" y="1917834"/>
             <a:ext cx="1660358" cy="360947"/>
           </a:xfrm>
           <a:prstGeom prst="roundRect">
@@ -18413,7 +18511,7 @@
         </p:nvSpPr>
         <p:spPr>
           <a:xfrm>
-            <a:off x="1199789" y="2509787"/>
+            <a:off x="1146850" y="2509787"/>
             <a:ext cx="1660358" cy="375385"/>
           </a:xfrm>
           <a:prstGeom prst="roundRect">
@@ -18463,7 +18561,7 @@
         </p:nvSpPr>
         <p:spPr>
           <a:xfrm>
-            <a:off x="1199789" y="3116179"/>
+            <a:off x="1146850" y="3116179"/>
             <a:ext cx="1660358" cy="375385"/>
           </a:xfrm>
           <a:prstGeom prst="roundRect">
@@ -18513,7 +18611,7 @@
         </p:nvSpPr>
         <p:spPr>
           <a:xfrm>
-            <a:off x="1199789" y="3722571"/>
+            <a:off x="1146850" y="3722571"/>
             <a:ext cx="1660358" cy="375385"/>
           </a:xfrm>
           <a:prstGeom prst="roundRect">
@@ -18563,7 +18661,7 @@
         </p:nvSpPr>
         <p:spPr>
           <a:xfrm>
-            <a:off x="1199789" y="4357838"/>
+            <a:off x="1146850" y="4357838"/>
             <a:ext cx="1660358" cy="693019"/>
           </a:xfrm>
           <a:prstGeom prst="diamond">
@@ -18631,7 +18729,7 @@
         </p:nvSpPr>
         <p:spPr>
           <a:xfrm>
-            <a:off x="3221094" y="4516655"/>
+            <a:off x="3168155" y="4516655"/>
             <a:ext cx="1515979" cy="375385"/>
           </a:xfrm>
           <a:prstGeom prst="roundRect">
@@ -18681,7 +18779,7 @@
         </p:nvSpPr>
         <p:spPr>
           <a:xfrm>
-            <a:off x="1199789" y="5296301"/>
+            <a:off x="1146850" y="5296301"/>
             <a:ext cx="1660358" cy="375385"/>
           </a:xfrm>
           <a:prstGeom prst="roundRect">
@@ -18731,7 +18829,7 @@
         </p:nvSpPr>
         <p:spPr>
           <a:xfrm>
-            <a:off x="4159557" y="5296301"/>
+            <a:off x="4106619" y="5296301"/>
             <a:ext cx="721895" cy="375385"/>
           </a:xfrm>
           <a:prstGeom prst="roundRect">
@@ -18781,7 +18879,7 @@
         </p:nvSpPr>
         <p:spPr>
           <a:xfrm>
-            <a:off x="2029968" y="2278781"/>
+            <a:off x="1977029" y="2278781"/>
             <a:ext cx="0" cy="187693"/>
           </a:xfrm>
           <a:prstGeom prst="line">
@@ -18805,7 +18903,7 @@
         </p:nvSpPr>
         <p:spPr>
           <a:xfrm>
-            <a:off x="2029968" y="2885173"/>
+            <a:off x="1977029" y="2885173"/>
             <a:ext cx="0" cy="187693"/>
           </a:xfrm>
           <a:prstGeom prst="line">
@@ -18829,7 +18927,7 @@
         </p:nvSpPr>
         <p:spPr>
           <a:xfrm>
-            <a:off x="2029968" y="3491564"/>
+            <a:off x="1977029" y="3491564"/>
             <a:ext cx="0" cy="187693"/>
           </a:xfrm>
           <a:prstGeom prst="line">
@@ -18853,7 +18951,7 @@
         </p:nvSpPr>
         <p:spPr>
           <a:xfrm>
-            <a:off x="2029968" y="4097956"/>
+            <a:off x="1977029" y="4097956"/>
             <a:ext cx="0" cy="216568"/>
           </a:xfrm>
           <a:prstGeom prst="line">
@@ -18877,7 +18975,7 @@
         </p:nvSpPr>
         <p:spPr>
           <a:xfrm>
-            <a:off x="2860147" y="4704347"/>
+            <a:off x="2807208" y="4704347"/>
             <a:ext cx="317634" cy="0"/>
           </a:xfrm>
           <a:prstGeom prst="line">
@@ -18901,7 +18999,7 @@
         </p:nvSpPr>
         <p:spPr>
           <a:xfrm>
-            <a:off x="2029968" y="5050857"/>
+            <a:off x="1977029" y="5050857"/>
             <a:ext cx="0" cy="202131"/>
           </a:xfrm>
           <a:prstGeom prst="line">
@@ -18925,7 +19023,7 @@
         </p:nvSpPr>
         <p:spPr>
           <a:xfrm>
-            <a:off x="3979084" y="4892040"/>
+            <a:off x="3926145" y="4892040"/>
             <a:ext cx="0" cy="274320"/>
           </a:xfrm>
           <a:prstGeom prst="line">
@@ -18948,7 +19046,7 @@
         </p:nvSpPr>
         <p:spPr>
           <a:xfrm flipH="1">
-            <a:off x="2499200" y="5166360"/>
+            <a:off x="2446261" y="5166360"/>
             <a:ext cx="1479884" cy="0"/>
           </a:xfrm>
           <a:prstGeom prst="line">
@@ -18971,7 +19069,7 @@
         </p:nvSpPr>
         <p:spPr>
           <a:xfrm>
-            <a:off x="2499200" y="5166360"/>
+            <a:off x="2446261" y="5166360"/>
             <a:ext cx="0" cy="86627"/>
           </a:xfrm>
           <a:prstGeom prst="line">
@@ -18995,7 +19093,7 @@
         </p:nvSpPr>
         <p:spPr>
           <a:xfrm>
-            <a:off x="2860147" y="5483994"/>
+            <a:off x="2807208" y="5483994"/>
             <a:ext cx="1256097" cy="0"/>
           </a:xfrm>
           <a:prstGeom prst="line">
@@ -19019,7 +19117,7 @@
         </p:nvSpPr>
         <p:spPr>
           <a:xfrm>
-            <a:off x="2917899" y="4509436"/>
+            <a:off x="2864960" y="4509436"/>
             <a:ext cx="288758" cy="158817"/>
           </a:xfrm>
           <a:prstGeom prst="rect">
@@ -19061,7 +19159,7 @@
         </p:nvSpPr>
         <p:spPr>
           <a:xfrm>
-            <a:off x="2109376" y="5072514"/>
+            <a:off x="2056437" y="5072514"/>
             <a:ext cx="288758" cy="158817"/>
           </a:xfrm>
           <a:prstGeom prst="rect">
@@ -19103,8 +19201,8 @@
         </p:nvSpPr>
         <p:spPr>
           <a:xfrm>
-            <a:off x="2946774" y="2618072"/>
-            <a:ext cx="1371600" cy="158817"/>
+            <a:off x="2893835" y="2596415"/>
+            <a:ext cx="1371600" cy="202131"/>
           </a:xfrm>
           <a:prstGeom prst="rect">
             <a:avLst/>
@@ -19142,8 +19240,8 @@
         </p:nvSpPr>
         <p:spPr>
           <a:xfrm>
-            <a:off x="2946774" y="3224463"/>
-            <a:ext cx="1371600" cy="158817"/>
+            <a:off x="2893835" y="3202806"/>
+            <a:ext cx="1371600" cy="202131"/>
           </a:xfrm>
           <a:prstGeom prst="rect">
             <a:avLst/>
@@ -19167,7 +19265,7 @@
                 <a:ea typeface="Arial" pitchFamily="34" charset="-122"/>
                 <a:cs typeface="Arial" pitchFamily="34" charset="-120"/>
               </a:rPr>
-              <a:t>IA · 12.000/mês</a:t>
+              <a:t>IA · alto volume</a:t>
             </a:r>
             <a:endParaRPr lang="en-US" sz="796" dirty="0"/>
           </a:p>
@@ -19181,8 +19279,8 @@
         </p:nvSpPr>
         <p:spPr>
           <a:xfrm>
-            <a:off x="2946774" y="3830855"/>
-            <a:ext cx="1371600" cy="158817"/>
+            <a:off x="2893835" y="3809198"/>
+            <a:ext cx="1371600" cy="202131"/>
           </a:xfrm>
           <a:prstGeom prst="rect">
             <a:avLst/>
@@ -19206,7 +19304,7 @@
                 <a:ea typeface="Arial" pitchFamily="34" charset="-122"/>
                 <a:cs typeface="Arial" pitchFamily="34" charset="-120"/>
               </a:rPr>
-              <a:t>IA · 9.000/mês + revisão</a:t>
+              <a:t>IA · alto volume + revisão</a:t>
             </a:r>
             <a:endParaRPr lang="en-US" sz="796" dirty="0"/>
           </a:p>
@@ -19220,8 +19318,8 @@
         </p:nvSpPr>
         <p:spPr>
           <a:xfrm>
-            <a:off x="4794825" y="4624939"/>
-            <a:ext cx="1010653" cy="158817"/>
+            <a:off x="4741886" y="4603282"/>
+            <a:ext cx="1515979" cy="202131"/>
           </a:xfrm>
           <a:prstGeom prst="rect">
             <a:avLst/>
@@ -19245,7 +19343,7 @@
                 <a:ea typeface="Arial" pitchFamily="34" charset="-122"/>
                 <a:cs typeface="Arial" pitchFamily="34" charset="-120"/>
               </a:rPr>
-              <a:t>HUMANO · 300/mês</a:t>
+              <a:t>HUMANO · baixo volume</a:t>
             </a:r>
             <a:endParaRPr lang="en-US" sz="796" dirty="0"/>
           </a:p>
@@ -19259,8 +19357,8 @@
         </p:nvSpPr>
         <p:spPr>
           <a:xfrm>
-            <a:off x="1199789" y="5743876"/>
-            <a:ext cx="721895" cy="158817"/>
+            <a:off x="1146850" y="5722219"/>
+            <a:ext cx="721895" cy="202131"/>
           </a:xfrm>
           <a:prstGeom prst="rect">
             <a:avLst/>
@@ -19678,7 +19776,7 @@
                 <a:ea typeface="Arial" pitchFamily="34" charset="-122"/>
                 <a:cs typeface="Arial" pitchFamily="34" charset="-120"/>
               </a:rPr>
-              <a:t>21 mil decisões ambíguas por mês com erro tolerável</a:t>
+              <a:t>decisão ambígua em alto volume, com erro tolerável</a:t>
             </a:r>
             <a:pPr indent="0" marL="0">
               <a:lnSpc>
@@ -19754,7 +19852,7 @@
                 <a:ea typeface="Arial" pitchFamily="34" charset="-122"/>
                 <a:cs typeface="Arial" pitchFamily="34" charset="-120"/>
               </a:rPr>
-              <a:t>300 julgamentos irreversíveis</a:t>
+              <a:t>poucos julgamentos, todos irreversíveis</a:t>
             </a:r>
             <a:pPr indent="0" marL="0">
               <a:lnSpc>

</xml_diff>

<commit_message>
Add a photo slot to the bio slide in both formats
The bio slide becomes a square portrait beside the identity block, with the
purple thesis panel moved below it. Both builds crop to square themselves
(object-fit: cover in HTML, sizing: cover in the pptx), so no pre-cropping
is needed; the framing point is tuned for a 3:4 portrait with the subject
slightly right of centre.

The photo is embedded as base64 because the Artifact CSP blocks external
images and the HTML has to stay self-contained. It is deliberately not
versioned — it is a real person's photograph and does not belong in the
repo. Without the file both decks render a marked placeholder and the build
prints a warning, so nothing breaks.

Verified end to end with a throwaway portrait of the same aspect ratio: the
data URI lands in deck.html and the image lands in ppt/media/ of the pptx.

Co-Authored-By: Claude Opus 5 <noreply@anthropic.com>
Claude-Session: https://claude.ai/code/session_01MoQxsSguKqzeKVWx2SGcrP
</commit_message>
<xml_diff>
--- a/talks/serasa-ia-automacao/deck.pptx
+++ b/talks/serasa-ia-automacao/deck.pptx
@@ -1043,7 +1043,8 @@
           <a:p>
             <a:r>
               <a:rPr lang="en-US" dirty="0"/>
-              <a:t>Credencial em 30 segundos, não currículo. A frase do painel escuro é a tese da palestra inteira: script / IA / pessoa. Ela volta no slide 8. ~1 min.</a:t>
+              <a:t>Credencial em 30 segundos, não currículo. A frase do painel escuro é a tese da palestra inteira: script / IA / pessoa. Ela volta no slide 8. ~1 min.
+PENDENTE: salvar a foto em assets/bruno.jpg e rodar node make_pptx.js de novo.</a:t>
             </a:r>
             <a:endParaRPr lang="en-US" dirty="0"/>
           </a:p>
@@ -9483,8 +9484,79 @@
         </p:nvSpPr>
         <p:spPr>
           <a:xfrm>
-            <a:off x="658368" y="1371600"/>
-            <a:ext cx="5943600" cy="777240"/>
+            <a:off x="658368" y="1600200"/>
+            <a:ext cx="2651760" cy="2651760"/>
+          </a:xfrm>
+          <a:prstGeom prst="roundRect">
+            <a:avLst>
+              <a:gd name="adj" fmla="val 4138"/>
+            </a:avLst>
+          </a:prstGeom>
+          <a:solidFill>
+            <a:srgbClr val="FEF6FA"/>
+          </a:solidFill>
+          <a:ln w="15875">
+            <a:solidFill>
+              <a:srgbClr val="E80070"/>
+            </a:solidFill>
+            <a:prstDash val="dash"/>
+          </a:ln>
+        </p:spPr>
+        <p:txBody>
+          <a:bodyPr wrap="square" lIns="0" tIns="0" rIns="0" bIns="0" rtlCol="0" anchor="ctr"/>
+          <a:lstStyle/>
+          <a:p>
+            <a:pPr algn="ctr" indent="0" marL="0">
+              <a:lnSpc>
+                <a:spcPts val="1400"/>
+              </a:lnSpc>
+              <a:buNone/>
+            </a:pPr>
+            <a:r>
+              <a:rPr lang="en-US" sz="950" i="1" dirty="0">
+                <a:solidFill>
+                  <a:srgbClr val="A08BAA"/>
+                </a:solidFill>
+                <a:latin typeface="Courier New" pitchFamily="34" charset="0"/>
+                <a:ea typeface="Courier New" pitchFamily="34" charset="-122"/>
+                <a:cs typeface="Courier New" pitchFamily="34" charset="-120"/>
+              </a:rPr>
+              <a:t>foto: salve em</a:t>
+            </a:r>
+            <a:endParaRPr lang="en-US" sz="950" dirty="0"/>
+          </a:p>
+          <a:p>
+            <a:pPr algn="ctr" indent="0" marL="0">
+              <a:lnSpc>
+                <a:spcPts val="1400"/>
+              </a:lnSpc>
+              <a:buNone/>
+            </a:pPr>
+            <a:r>
+              <a:rPr lang="en-US" sz="950" i="1" dirty="0">
+                <a:solidFill>
+                  <a:srgbClr val="A08BAA"/>
+                </a:solidFill>
+                <a:latin typeface="Courier New" pitchFamily="34" charset="0"/>
+                <a:ea typeface="Courier New" pitchFamily="34" charset="-122"/>
+                <a:cs typeface="Courier New" pitchFamily="34" charset="-120"/>
+              </a:rPr>
+              <a:t>assets/bruno.jpg</a:t>
+            </a:r>
+            <a:endParaRPr lang="en-US" sz="950" dirty="0"/>
+          </a:p>
+        </p:txBody>
+      </p:sp>
+      <p:sp>
+        <p:nvSpPr>
+          <p:cNvPr id="5" name="Text 3"/>
+          <p:cNvSpPr/>
+          <p:nvPr/>
+        </p:nvSpPr>
+        <p:spPr>
+          <a:xfrm>
+            <a:off x="3813048" y="1536192"/>
+            <a:ext cx="5029200" cy="777240"/>
           </a:xfrm>
           <a:prstGeom prst="rect">
             <a:avLst/>
@@ -9516,14 +9588,14 @@
       </p:sp>
       <p:sp>
         <p:nvSpPr>
-          <p:cNvPr id="5" name="Text 3"/>
-          <p:cNvSpPr/>
-          <p:nvPr/>
-        </p:nvSpPr>
-        <p:spPr>
-          <a:xfrm>
-            <a:off x="658368" y="2194560"/>
-            <a:ext cx="5943600" cy="365760"/>
+          <p:cNvPr id="6" name="Text 4"/>
+          <p:cNvSpPr/>
+          <p:nvPr/>
+        </p:nvSpPr>
+        <p:spPr>
+          <a:xfrm>
+            <a:off x="3813048" y="2286000"/>
+            <a:ext cx="5486400" cy="365760"/>
           </a:xfrm>
           <a:prstGeom prst="rect">
             <a:avLst/>
@@ -9569,13 +9641,13 @@
       </p:sp>
       <p:sp>
         <p:nvSpPr>
-          <p:cNvPr id="6" name="Text 4"/>
-          <p:cNvSpPr/>
-          <p:nvPr/>
-        </p:nvSpPr>
-        <p:spPr>
-          <a:xfrm>
-            <a:off x="658368" y="2834640"/>
+          <p:cNvPr id="7" name="Text 5"/>
+          <p:cNvSpPr/>
+          <p:nvPr/>
+        </p:nvSpPr>
+        <p:spPr>
+          <a:xfrm>
+            <a:off x="3813048" y="2871216"/>
             <a:ext cx="1691640" cy="329184"/>
           </a:xfrm>
           <a:prstGeom prst="roundRect">
@@ -9612,13 +9684,13 @@
       </p:sp>
       <p:sp>
         <p:nvSpPr>
-          <p:cNvPr id="7" name="Text 5"/>
-          <p:cNvSpPr/>
-          <p:nvPr/>
-        </p:nvSpPr>
-        <p:spPr>
-          <a:xfrm>
-            <a:off x="2478024" y="2834640"/>
+          <p:cNvPr id="8" name="Text 6"/>
+          <p:cNvSpPr/>
+          <p:nvPr/>
+        </p:nvSpPr>
+        <p:spPr>
+          <a:xfrm>
+            <a:off x="5632704" y="2871216"/>
             <a:ext cx="868680" cy="329184"/>
           </a:xfrm>
           <a:prstGeom prst="roundRect">
@@ -9655,13 +9727,13 @@
       </p:sp>
       <p:sp>
         <p:nvSpPr>
-          <p:cNvPr id="8" name="Text 6"/>
-          <p:cNvSpPr/>
-          <p:nvPr/>
-        </p:nvSpPr>
-        <p:spPr>
-          <a:xfrm>
-            <a:off x="3474720" y="2834640"/>
+          <p:cNvPr id="9" name="Text 7"/>
+          <p:cNvSpPr/>
+          <p:nvPr/>
+        </p:nvSpPr>
+        <p:spPr>
+          <a:xfrm>
+            <a:off x="6629400" y="2871216"/>
             <a:ext cx="1005840" cy="329184"/>
           </a:xfrm>
           <a:prstGeom prst="roundRect">
@@ -9698,13 +9770,13 @@
       </p:sp>
       <p:sp>
         <p:nvSpPr>
-          <p:cNvPr id="9" name="Text 7"/>
-          <p:cNvSpPr/>
-          <p:nvPr/>
-        </p:nvSpPr>
-        <p:spPr>
-          <a:xfrm>
-            <a:off x="4608576" y="2834640"/>
+          <p:cNvPr id="10" name="Text 8"/>
+          <p:cNvSpPr/>
+          <p:nvPr/>
+        </p:nvSpPr>
+        <p:spPr>
+          <a:xfrm>
+            <a:off x="7763256" y="2871216"/>
             <a:ext cx="1051560" cy="329184"/>
           </a:xfrm>
           <a:prstGeom prst="roundRect">
@@ -9741,14 +9813,14 @@
       </p:sp>
       <p:sp>
         <p:nvSpPr>
-          <p:cNvPr id="10" name="Text 8"/>
-          <p:cNvSpPr/>
-          <p:nvPr/>
-        </p:nvSpPr>
-        <p:spPr>
-          <a:xfrm>
-            <a:off x="658368" y="3346704"/>
-            <a:ext cx="5943600" cy="274320"/>
+          <p:cNvPr id="11" name="Text 9"/>
+          <p:cNvSpPr/>
+          <p:nvPr/>
+        </p:nvSpPr>
+        <p:spPr>
+          <a:xfrm>
+            <a:off x="3813048" y="3401568"/>
+            <a:ext cx="5486400" cy="274320"/>
           </a:xfrm>
           <a:prstGeom prst="rect">
             <a:avLst/>
@@ -9780,18 +9852,18 @@
       </p:sp>
       <p:sp>
         <p:nvSpPr>
-          <p:cNvPr id="11" name="Shape 9"/>
-          <p:cNvSpPr/>
-          <p:nvPr/>
-        </p:nvSpPr>
-        <p:spPr>
-          <a:xfrm>
-            <a:off x="7040880" y="1325880"/>
-            <a:ext cx="4480560" cy="2377440"/>
+          <p:cNvPr id="12" name="Shape 10"/>
+          <p:cNvSpPr/>
+          <p:nvPr/>
+        </p:nvSpPr>
+        <p:spPr>
+          <a:xfrm>
+            <a:off x="3813048" y="3950208"/>
+            <a:ext cx="7720279" cy="1417320"/>
           </a:xfrm>
           <a:prstGeom prst="roundRect">
             <a:avLst>
-              <a:gd name="adj" fmla="val 5000"/>
+              <a:gd name="adj" fmla="val 8387"/>
             </a:avLst>
           </a:prstGeom>
           <a:solidFill>
@@ -9807,13 +9879,13 @@
       </p:sp>
       <p:sp>
         <p:nvSpPr>
-          <p:cNvPr id="12" name="Text 10"/>
-          <p:cNvSpPr/>
-          <p:nvPr/>
-        </p:nvSpPr>
-        <p:spPr>
-          <a:xfrm>
-            <a:off x="7296912" y="1536192"/>
+          <p:cNvPr id="13" name="Text 11"/>
+          <p:cNvSpPr/>
+          <p:nvPr/>
+        </p:nvSpPr>
+        <p:spPr>
+          <a:xfrm>
+            <a:off x="4087368" y="4114800"/>
             <a:ext cx="3931920" cy="219456"/>
           </a:xfrm>
           <a:prstGeom prst="rect">
@@ -9846,14 +9918,14 @@
       </p:sp>
       <p:sp>
         <p:nvSpPr>
-          <p:cNvPr id="13" name="Text 11"/>
-          <p:cNvSpPr/>
-          <p:nvPr/>
-        </p:nvSpPr>
-        <p:spPr>
-          <a:xfrm>
-            <a:off x="7296912" y="1810512"/>
-            <a:ext cx="3968496" cy="1737360"/>
+          <p:cNvPr id="14" name="Text 12"/>
+          <p:cNvSpPr/>
+          <p:nvPr/>
+        </p:nvSpPr>
+        <p:spPr>
+          <a:xfrm>
+            <a:off x="4087368" y="4370832"/>
+            <a:ext cx="7171639" cy="914400"/>
           </a:xfrm>
           <a:prstGeom prst="rect">
             <a:avLst/>
@@ -9867,12 +9939,12 @@
           <a:p>
             <a:pPr indent="0" marL="0">
               <a:lnSpc>
-                <a:spcPts val="1850"/>
-              </a:lnSpc>
-              <a:buNone/>
-            </a:pPr>
-            <a:r>
-              <a:rPr lang="en-US" sz="1300" dirty="0">
+                <a:spcPts val="1900"/>
+              </a:lnSpc>
+              <a:buNone/>
+            </a:pPr>
+            <a:r>
+              <a:rPr lang="en-US" sz="1250" dirty="0">
                 <a:solidFill>
                   <a:srgbClr val="EDE4F3"/>
                 </a:solidFill>
@@ -9884,12 +9956,12 @@
             </a:r>
             <a:pPr indent="0" marL="0">
               <a:lnSpc>
-                <a:spcPts val="1850"/>
-              </a:lnSpc>
-              <a:buNone/>
-            </a:pPr>
-            <a:r>
-              <a:rPr lang="en-US" sz="1300" b="1" dirty="0">
+                <a:spcPts val="1900"/>
+              </a:lnSpc>
+              <a:buNone/>
+            </a:pPr>
+            <a:r>
+              <a:rPr lang="en-US" sz="1250" b="1" dirty="0">
                 <a:solidFill>
                   <a:srgbClr val="FFFFFF"/>
                 </a:solidFill>
@@ -9901,12 +9973,12 @@
             </a:r>
             <a:pPr indent="0" marL="0">
               <a:lnSpc>
-                <a:spcPts val="1850"/>
-              </a:lnSpc>
-              <a:buNone/>
-            </a:pPr>
-            <a:r>
-              <a:rPr lang="en-US" sz="1300" dirty="0">
+                <a:spcPts val="1900"/>
+              </a:lnSpc>
+              <a:buNone/>
+            </a:pPr>
+            <a:r>
+              <a:rPr lang="en-US" sz="1250" dirty="0">
                 <a:solidFill>
                   <a:srgbClr val="EDE4F3"/>
                 </a:solidFill>
@@ -9916,13 +9988,13 @@
               </a:rPr>
               <a:t>.</a:t>
             </a:r>
-            <a:endParaRPr lang="en-US" sz="1300" dirty="0"/>
-          </a:p>
-        </p:txBody>
-      </p:sp>
-      <p:sp>
-        <p:nvSpPr>
-          <p:cNvPr id="14" name="Text 12"/>
+            <a:endParaRPr lang="en-US" sz="1250" dirty="0"/>
+          </a:p>
+        </p:txBody>
+      </p:sp>
+      <p:sp>
+        <p:nvSpPr>
+          <p:cNvPr id="15" name="Text 13"/>
           <p:cNvSpPr/>
           <p:nvPr/>
         </p:nvSpPr>
@@ -9961,7 +10033,7 @@
       </p:sp>
       <p:sp>
         <p:nvSpPr>
-          <p:cNvPr id="15" name="Text 13"/>
+          <p:cNvPr id="16" name="Text 14"/>
           <p:cNvSpPr/>
           <p:nvPr/>
         </p:nvSpPr>

</xml_diff>

<commit_message>
Rebuild the opening slide as two comparable cards
The two questions sat as bare columns on the gradient with the same label
on both, no surface to separate them, and the verdict buried in a
body-sized sentence at the bottom. There was nothing to compare against
anything.

Now they are two cards with identical anatomy — tag, question, separator,
the answer that comes back, and what you end up with — so the eye can put
them side by side. The differing part is the last line, set large and in
the same position on both: 'uma solução' against 'o processo'. The second
card carries the magenta treatment so the recommendation needs no reading.

Co-Authored-By: Claude Opus 5 <noreply@anthropic.com>
Claude-Session: https://claude.ai/code/session_01MoQxsSguKqzeKVWx2SGcrP
</commit_message>
<xml_diff>
--- a/talks/serasa-ia-automacao/deck.pptx
+++ b/talks/serasa-ia-automacao/deck.pptx
@@ -1132,7 +1132,7 @@
           <a:p>
             <a:r>
               <a:rPr lang="en-US" dirty="0"/>
-              <a:t>Não é 'vocês perguntam errado'. É que a primeira pergunta pede um julgamento e a segunda pede uma memória — e memória sai mais fiel. Leia as duas respostas em voz alta. ~1,5 min.</a:t>
+              <a:t>As duas cartas têm a mesma anatomia de propósito: a plateia compara direto o desfecho, 'uma solução' contra 'o processo'. Não é que a pergunta 1 seja proibida — ela pede um julgamento, e a 2 pede uma memória. ~1,5 min.</a:t>
             </a:r>
             <a:endParaRPr lang="en-US" dirty="0"/>
           </a:p>
@@ -10150,7 +10150,7 @@
         <p:spPr>
           <a:xfrm>
             <a:off x="658368" y="1234440"/>
-            <a:ext cx="10424160" cy="1005840"/>
+            <a:ext cx="10424160" cy="548640"/>
           </a:xfrm>
           <a:prstGeom prst="rect">
             <a:avLst/>
@@ -10163,13 +10163,10 @@
           <a:lstStyle/>
           <a:p>
             <a:pPr indent="0" marL="0">
-              <a:lnSpc>
-                <a:spcPts val="3000"/>
-              </a:lnSpc>
-              <a:buNone/>
-            </a:pPr>
-            <a:r>
-              <a:rPr lang="en-US" sz="2800" b="1" spc="-62" kern="0" dirty="0">
+              <a:buNone/>
+            </a:pPr>
+            <a:r>
+              <a:rPr lang="en-US" sz="2900" b="1" spc="-64" kern="0" dirty="0">
                 <a:solidFill>
                   <a:srgbClr val="FFFFFF"/>
                 </a:solidFill>
@@ -10177,16 +10174,13 @@
                 <a:ea typeface="Arial" pitchFamily="34" charset="-122"/>
                 <a:cs typeface="Arial" pitchFamily="34" charset="-120"/>
               </a:rPr>
-              <a:t>A mesma conversa, duas perguntas — </a:t>
-            </a:r>
-            <a:pPr indent="0" marL="0">
-              <a:lnSpc>
-                <a:spcPts val="3000"/>
-              </a:lnSpc>
-              <a:buNone/>
-            </a:pPr>
-            <a:r>
-              <a:rPr lang="en-US" sz="2800" b="1" spc="-62" kern="0" dirty="0">
+              <a:t>Duas perguntas para o </a:t>
+            </a:r>
+            <a:pPr indent="0" marL="0">
+              <a:buNone/>
+            </a:pPr>
+            <a:r>
+              <a:rPr lang="en-US" sz="2900" b="1" spc="-64" kern="0" dirty="0">
                 <a:solidFill>
                   <a:srgbClr val="FF8FC0"/>
                 </a:solidFill>
@@ -10194,22 +10188,49 @@
                 <a:ea typeface="Arial" pitchFamily="34" charset="-122"/>
                 <a:cs typeface="Arial" pitchFamily="34" charset="-120"/>
               </a:rPr>
-              <a:t>e respostas muito diferentes</a:t>
-            </a:r>
-            <a:endParaRPr lang="en-US" sz="2800" dirty="0"/>
-          </a:p>
-        </p:txBody>
-      </p:sp>
-      <p:sp>
-        <p:nvSpPr>
-          <p:cNvPr id="4" name="Text 2"/>
-          <p:cNvSpPr/>
-          <p:nvPr/>
-        </p:nvSpPr>
-        <p:spPr>
-          <a:xfrm>
-            <a:off x="658368" y="2487168"/>
-            <a:ext cx="4937760" cy="219456"/>
+              <a:t>mesmo processo</a:t>
+            </a:r>
+            <a:endParaRPr lang="en-US" sz="2900" dirty="0"/>
+          </a:p>
+        </p:txBody>
+      </p:sp>
+      <p:sp>
+        <p:nvSpPr>
+          <p:cNvPr id="4" name="Shape 2"/>
+          <p:cNvSpPr/>
+          <p:nvPr/>
+        </p:nvSpPr>
+        <p:spPr>
+          <a:xfrm>
+            <a:off x="658368" y="1965960"/>
+            <a:ext cx="5254600" cy="3108960"/>
+          </a:xfrm>
+          <a:prstGeom prst="roundRect">
+            <a:avLst>
+              <a:gd name="adj" fmla="val 3235"/>
+            </a:avLst>
+          </a:prstGeom>
+          <a:solidFill>
+            <a:srgbClr val="5C2470"/>
+          </a:solidFill>
+          <a:ln w="12700">
+            <a:solidFill>
+              <a:srgbClr val="8E6FA6"/>
+            </a:solidFill>
+            <a:prstDash val="solid"/>
+          </a:ln>
+        </p:spPr>
+      </p:sp>
+      <p:sp>
+        <p:nvSpPr>
+          <p:cNvPr id="5" name="Text 3"/>
+          <p:cNvSpPr/>
+          <p:nvPr/>
+        </p:nvSpPr>
+        <p:spPr>
+          <a:xfrm>
+            <a:off x="950976" y="2203704"/>
+            <a:ext cx="4669384" cy="201168"/>
           </a:xfrm>
           <a:prstGeom prst="rect">
             <a:avLst/>
@@ -10225,7 +10246,7 @@
               <a:buNone/>
             </a:pPr>
             <a:r>
-              <a:rPr lang="en-US" sz="850" spc="120" kern="0" dirty="0">
+              <a:rPr lang="en-US" sz="900" b="1" spc="130" kern="0" dirty="0">
                 <a:solidFill>
                   <a:srgbClr val="B79ACB"/>
                 </a:solidFill>
@@ -10233,22 +10254,22 @@
                 <a:ea typeface="Courier New" pitchFamily="34" charset="-122"/>
                 <a:cs typeface="Courier New" pitchFamily="34" charset="-120"/>
               </a:rPr>
-              <a:t>SE A PERGUNTA É</a:t>
-            </a:r>
-            <a:endParaRPr lang="en-US" sz="850" dirty="0"/>
-          </a:p>
-        </p:txBody>
-      </p:sp>
-      <p:sp>
-        <p:nvSpPr>
-          <p:cNvPr id="5" name="Text 3"/>
-          <p:cNvSpPr/>
-          <p:nvPr/>
-        </p:nvSpPr>
-        <p:spPr>
-          <a:xfrm>
-            <a:off x="658368" y="2743200"/>
-            <a:ext cx="4937760" cy="713232"/>
+              <a:t>PERGUNTA 1</a:t>
+            </a:r>
+            <a:endParaRPr lang="en-US" sz="900" dirty="0"/>
+          </a:p>
+        </p:txBody>
+      </p:sp>
+      <p:sp>
+        <p:nvSpPr>
+          <p:cNvPr id="6" name="Text 4"/>
+          <p:cNvSpPr/>
+          <p:nvPr/>
+        </p:nvSpPr>
+        <p:spPr>
+          <a:xfrm>
+            <a:off x="950976" y="2496312"/>
+            <a:ext cx="4669384" cy="804672"/>
           </a:xfrm>
           <a:prstGeom prst="rect">
             <a:avLst/>
@@ -10262,12 +10283,12 @@
           <a:p>
             <a:pPr indent="0" marL="0">
               <a:lnSpc>
-                <a:spcPts val="2500"/>
-              </a:lnSpc>
-              <a:buNone/>
-            </a:pPr>
-            <a:r>
-              <a:rPr lang="en-US" sz="1900" spc="-19" kern="0" dirty="0">
+                <a:spcPts val="2400"/>
+              </a:lnSpc>
+              <a:buNone/>
+            </a:pPr>
+            <a:r>
+              <a:rPr lang="en-US" sz="1800" spc="-18" kern="0" dirty="0">
                 <a:solidFill>
                   <a:srgbClr val="FFFFFF"/>
                 </a:solidFill>
@@ -10277,26 +10298,26 @@
               </a:rPr>
               <a:t>“O que vocês querem automatizar?”</a:t>
             </a:r>
-            <a:endParaRPr lang="en-US" sz="1900" dirty="0"/>
-          </a:p>
-        </p:txBody>
-      </p:sp>
-      <p:sp>
-        <p:nvSpPr>
-          <p:cNvPr id="6" name="Shape 4"/>
-          <p:cNvSpPr/>
-          <p:nvPr/>
-        </p:nvSpPr>
-        <p:spPr>
-          <a:xfrm>
-            <a:off x="658368" y="3584448"/>
-            <a:ext cx="32004" cy="475488"/>
+            <a:endParaRPr lang="en-US" sz="1800" dirty="0"/>
+          </a:p>
+        </p:txBody>
+      </p:sp>
+      <p:sp>
+        <p:nvSpPr>
+          <p:cNvPr id="7" name="Shape 5"/>
+          <p:cNvSpPr/>
+          <p:nvPr/>
+        </p:nvSpPr>
+        <p:spPr>
+          <a:xfrm>
+            <a:off x="950976" y="3410712"/>
+            <a:ext cx="4669384" cy="10973"/>
           </a:xfrm>
           <a:prstGeom prst="rect">
             <a:avLst/>
           </a:prstGeom>
           <a:solidFill>
-            <a:srgbClr val="8E7FA0"/>
+            <a:srgbClr val="8E6FA6"/>
           </a:solidFill>
           <a:ln w="12700">
             <a:solidFill>
@@ -10308,132 +10329,14 @@
       </p:sp>
       <p:sp>
         <p:nvSpPr>
-          <p:cNvPr id="7" name="Text 5"/>
-          <p:cNvSpPr/>
-          <p:nvPr/>
-        </p:nvSpPr>
-        <p:spPr>
-          <a:xfrm>
-            <a:off x="841248" y="3566160"/>
-            <a:ext cx="4754880" cy="512064"/>
-          </a:xfrm>
-          <a:prstGeom prst="rect">
-            <a:avLst/>
-          </a:prstGeom>
-          <a:noFill/>
-          <a:ln/>
-        </p:spPr>
-        <p:txBody>
-          <a:bodyPr wrap="square" lIns="0" tIns="0" rIns="0" bIns="0" rtlCol="0" anchor="t"/>
-          <a:lstStyle/>
-          <a:p>
-            <a:pPr indent="0" marL="0">
-              <a:lnSpc>
-                <a:spcPts val="1850"/>
-              </a:lnSpc>
-              <a:buNone/>
-            </a:pPr>
-            <a:r>
-              <a:rPr lang="en-US" sz="1300" i="1" dirty="0">
-                <a:solidFill>
-                  <a:srgbClr val="D9C8E4"/>
-                </a:solidFill>
-                <a:latin typeface="Arial" pitchFamily="34" charset="0"/>
-                <a:ea typeface="Arial" pitchFamily="34" charset="-122"/>
-                <a:cs typeface="Arial" pitchFamily="34" charset="-120"/>
-              </a:rPr>
-              <a:t>“Queria um bot que respondesse os chamados.”</a:t>
-            </a:r>
-            <a:endParaRPr lang="en-US" sz="1300" dirty="0"/>
-          </a:p>
-        </p:txBody>
-      </p:sp>
-      <p:sp>
-        <p:nvSpPr>
           <p:cNvPr id="8" name="Text 6"/>
           <p:cNvSpPr/>
           <p:nvPr/>
         </p:nvSpPr>
         <p:spPr>
           <a:xfrm>
-            <a:off x="658368" y="4206240"/>
-            <a:ext cx="4937760" cy="512064"/>
-          </a:xfrm>
-          <a:prstGeom prst="rect">
-            <a:avLst/>
-          </a:prstGeom>
-          <a:noFill/>
-          <a:ln/>
-        </p:spPr>
-        <p:txBody>
-          <a:bodyPr wrap="square" lIns="0" tIns="0" rIns="0" bIns="0" rtlCol="0" anchor="t"/>
-          <a:lstStyle/>
-          <a:p>
-            <a:pPr indent="0" marL="0">
-              <a:lnSpc>
-                <a:spcPts val="1900"/>
-              </a:lnSpc>
-              <a:buNone/>
-            </a:pPr>
-            <a:r>
-              <a:rPr lang="en-US" sz="1250" dirty="0">
-                <a:solidFill>
-                  <a:srgbClr val="EDE4F3"/>
-                </a:solidFill>
-                <a:latin typeface="Arial" pitchFamily="34" charset="0"/>
-                <a:ea typeface="Arial" pitchFamily="34" charset="-122"/>
-                <a:cs typeface="Arial" pitchFamily="34" charset="-120"/>
-              </a:rPr>
-              <a:t>Vem </a:t>
-            </a:r>
-            <a:pPr indent="0" marL="0">
-              <a:lnSpc>
-                <a:spcPts val="1900"/>
-              </a:lnSpc>
-              <a:buNone/>
-            </a:pPr>
-            <a:r>
-              <a:rPr lang="en-US" sz="1250" b="1" dirty="0">
-                <a:solidFill>
-                  <a:srgbClr val="FFFFFF"/>
-                </a:solidFill>
-                <a:latin typeface="Arial" pitchFamily="34" charset="0"/>
-                <a:ea typeface="Arial" pitchFamily="34" charset="-122"/>
-                <a:cs typeface="Arial" pitchFamily="34" charset="-120"/>
-              </a:rPr>
-              <a:t>uma solução pronta</a:t>
-            </a:r>
-            <a:pPr indent="0" marL="0">
-              <a:lnSpc>
-                <a:spcPts val="1900"/>
-              </a:lnSpc>
-              <a:buNone/>
-            </a:pPr>
-            <a:r>
-              <a:rPr lang="en-US" sz="1250" dirty="0">
-                <a:solidFill>
-                  <a:srgbClr val="EDE4F3"/>
-                </a:solidFill>
-                <a:latin typeface="Arial" pitchFamily="34" charset="0"/>
-                <a:ea typeface="Arial" pitchFamily="34" charset="-122"/>
-                <a:cs typeface="Arial" pitchFamily="34" charset="-120"/>
-              </a:rPr>
-              <a:t> — sem o processo que ela deveria resolver.</a:t>
-            </a:r>
-            <a:endParaRPr lang="en-US" sz="1250" dirty="0"/>
-          </a:p>
-        </p:txBody>
-      </p:sp>
-      <p:sp>
-        <p:nvSpPr>
-          <p:cNvPr id="9" name="Text 7"/>
-          <p:cNvSpPr/>
-          <p:nvPr/>
-        </p:nvSpPr>
-        <p:spPr>
-          <a:xfrm>
-            <a:off x="6400800" y="2487168"/>
-            <a:ext cx="4937760" cy="219456"/>
+            <a:off x="950976" y="3557016"/>
+            <a:ext cx="4669384" cy="182880"/>
           </a:xfrm>
           <a:prstGeom prst="rect">
             <a:avLst/>
@@ -10449,17 +10352,59 @@
               <a:buNone/>
             </a:pPr>
             <a:r>
-              <a:rPr lang="en-US" sz="850" b="1" spc="120" kern="0" dirty="0">
-                <a:solidFill>
-                  <a:srgbClr val="FF8FC0"/>
+              <a:rPr lang="en-US" sz="800" spc="110" kern="0" dirty="0">
+                <a:solidFill>
+                  <a:srgbClr val="9B84AE"/>
                 </a:solidFill>
                 <a:latin typeface="Courier New" pitchFamily="34" charset="0"/>
                 <a:ea typeface="Courier New" pitchFamily="34" charset="-122"/>
                 <a:cs typeface="Courier New" pitchFamily="34" charset="-120"/>
               </a:rPr>
-              <a:t>SE A PERGUNTA É</a:t>
-            </a:r>
-            <a:endParaRPr lang="en-US" sz="850" dirty="0"/>
+              <a:t>A RESPOSTA QUE VEM</a:t>
+            </a:r>
+            <a:endParaRPr lang="en-US" sz="800" dirty="0"/>
+          </a:p>
+        </p:txBody>
+      </p:sp>
+      <p:sp>
+        <p:nvSpPr>
+          <p:cNvPr id="9" name="Text 7"/>
+          <p:cNvSpPr/>
+          <p:nvPr/>
+        </p:nvSpPr>
+        <p:spPr>
+          <a:xfrm>
+            <a:off x="950976" y="3758184"/>
+            <a:ext cx="4669384" cy="548640"/>
+          </a:xfrm>
+          <a:prstGeom prst="rect">
+            <a:avLst/>
+          </a:prstGeom>
+          <a:noFill/>
+          <a:ln/>
+        </p:spPr>
+        <p:txBody>
+          <a:bodyPr wrap="square" lIns="0" tIns="0" rIns="0" bIns="0" rtlCol="0" anchor="t"/>
+          <a:lstStyle/>
+          <a:p>
+            <a:pPr indent="0" marL="0">
+              <a:lnSpc>
+                <a:spcPts val="1700"/>
+              </a:lnSpc>
+              <a:buNone/>
+            </a:pPr>
+            <a:r>
+              <a:rPr lang="en-US" sz="1150" i="1" dirty="0">
+                <a:solidFill>
+                  <a:srgbClr val="DCCCE7"/>
+                </a:solidFill>
+                <a:latin typeface="Arial" pitchFamily="34" charset="0"/>
+                <a:ea typeface="Arial" pitchFamily="34" charset="-122"/>
+                <a:cs typeface="Arial" pitchFamily="34" charset="-120"/>
+              </a:rPr>
+              <a:t>“Queria um bot que respondesse os chamados.”</a:t>
+            </a:r>
+            <a:endParaRPr lang="en-US" sz="1150" dirty="0"/>
           </a:p>
         </p:txBody>
       </p:sp>
@@ -10471,8 +10416,47 @@
         </p:nvSpPr>
         <p:spPr>
           <a:xfrm>
-            <a:off x="6400800" y="2743200"/>
-            <a:ext cx="4937760" cy="713232"/>
+            <a:off x="950976" y="4361688"/>
+            <a:ext cx="4669384" cy="182880"/>
+          </a:xfrm>
+          <a:prstGeom prst="rect">
+            <a:avLst/>
+          </a:prstGeom>
+          <a:noFill/>
+          <a:ln/>
+        </p:spPr>
+        <p:txBody>
+          <a:bodyPr wrap="square" lIns="0" tIns="0" rIns="0" bIns="0" rtlCol="0" anchor="ctr"/>
+          <a:lstStyle/>
+          <a:p>
+            <a:pPr indent="0" marL="0">
+              <a:buNone/>
+            </a:pPr>
+            <a:r>
+              <a:rPr lang="en-US" sz="800" spc="110" kern="0" dirty="0">
+                <a:solidFill>
+                  <a:srgbClr val="9B84AE"/>
+                </a:solidFill>
+                <a:latin typeface="Courier New" pitchFamily="34" charset="0"/>
+                <a:ea typeface="Courier New" pitchFamily="34" charset="-122"/>
+                <a:cs typeface="Courier New" pitchFamily="34" charset="-120"/>
+              </a:rPr>
+              <a:t>VOCÊ RECEBE</a:t>
+            </a:r>
+            <a:endParaRPr lang="en-US" sz="800" dirty="0"/>
+          </a:p>
+        </p:txBody>
+      </p:sp>
+      <p:sp>
+        <p:nvSpPr>
+          <p:cNvPr id="11" name="Text 9"/>
+          <p:cNvSpPr/>
+          <p:nvPr/>
+        </p:nvSpPr>
+        <p:spPr>
+          <a:xfrm>
+            <a:off x="950976" y="4562856"/>
+            <a:ext cx="4669384" cy="420624"/>
           </a:xfrm>
           <a:prstGeom prst="rect">
             <a:avLst/>
@@ -10485,13 +10469,118 @@
           <a:lstStyle/>
           <a:p>
             <a:pPr indent="0" marL="0">
-              <a:lnSpc>
-                <a:spcPts val="2500"/>
-              </a:lnSpc>
-              <a:buNone/>
-            </a:pPr>
-            <a:r>
-              <a:rPr lang="en-US" sz="1900" spc="-19" kern="0" dirty="0">
+              <a:buNone/>
+            </a:pPr>
+            <a:r>
+              <a:rPr lang="en-US" sz="2400" b="1" spc="-53" kern="0" dirty="0">
+                <a:solidFill>
+                  <a:srgbClr val="EDE4F3"/>
+                </a:solidFill>
+                <a:latin typeface="Arial" pitchFamily="34" charset="0"/>
+                <a:ea typeface="Arial" pitchFamily="34" charset="-122"/>
+                <a:cs typeface="Arial" pitchFamily="34" charset="-120"/>
+              </a:rPr>
+              <a:t>uma solução</a:t>
+            </a:r>
+            <a:endParaRPr lang="en-US" sz="2400" dirty="0"/>
+          </a:p>
+        </p:txBody>
+      </p:sp>
+      <p:sp>
+        <p:nvSpPr>
+          <p:cNvPr id="12" name="Shape 10"/>
+          <p:cNvSpPr/>
+          <p:nvPr/>
+        </p:nvSpPr>
+        <p:spPr>
+          <a:xfrm>
+            <a:off x="6278728" y="1965960"/>
+            <a:ext cx="5254600" cy="3108960"/>
+          </a:xfrm>
+          <a:prstGeom prst="roundRect">
+            <a:avLst>
+              <a:gd name="adj" fmla="val 3235"/>
+            </a:avLst>
+          </a:prstGeom>
+          <a:solidFill>
+            <a:srgbClr val="6A1350"/>
+          </a:solidFill>
+          <a:ln w="12700">
+            <a:solidFill>
+              <a:srgbClr val="FF8FC0"/>
+            </a:solidFill>
+            <a:prstDash val="solid"/>
+          </a:ln>
+        </p:spPr>
+      </p:sp>
+      <p:sp>
+        <p:nvSpPr>
+          <p:cNvPr id="13" name="Text 11"/>
+          <p:cNvSpPr/>
+          <p:nvPr/>
+        </p:nvSpPr>
+        <p:spPr>
+          <a:xfrm>
+            <a:off x="6571336" y="2203704"/>
+            <a:ext cx="4669384" cy="201168"/>
+          </a:xfrm>
+          <a:prstGeom prst="rect">
+            <a:avLst/>
+          </a:prstGeom>
+          <a:noFill/>
+          <a:ln/>
+        </p:spPr>
+        <p:txBody>
+          <a:bodyPr wrap="square" lIns="0" tIns="0" rIns="0" bIns="0" rtlCol="0" anchor="ctr"/>
+          <a:lstStyle/>
+          <a:p>
+            <a:pPr indent="0" marL="0">
+              <a:buNone/>
+            </a:pPr>
+            <a:r>
+              <a:rPr lang="en-US" sz="900" b="1" spc="130" kern="0" dirty="0">
+                <a:solidFill>
+                  <a:srgbClr val="FF8FC0"/>
+                </a:solidFill>
+                <a:latin typeface="Courier New" pitchFamily="34" charset="0"/>
+                <a:ea typeface="Courier New" pitchFamily="34" charset="-122"/>
+                <a:cs typeface="Courier New" pitchFamily="34" charset="-120"/>
+              </a:rPr>
+              <a:t>PERGUNTA 2</a:t>
+            </a:r>
+            <a:endParaRPr lang="en-US" sz="900" dirty="0"/>
+          </a:p>
+        </p:txBody>
+      </p:sp>
+      <p:sp>
+        <p:nvSpPr>
+          <p:cNvPr id="14" name="Text 12"/>
+          <p:cNvSpPr/>
+          <p:nvPr/>
+        </p:nvSpPr>
+        <p:spPr>
+          <a:xfrm>
+            <a:off x="6571336" y="2496312"/>
+            <a:ext cx="4669384" cy="804672"/>
+          </a:xfrm>
+          <a:prstGeom prst="rect">
+            <a:avLst/>
+          </a:prstGeom>
+          <a:noFill/>
+          <a:ln/>
+        </p:spPr>
+        <p:txBody>
+          <a:bodyPr wrap="square" lIns="0" tIns="0" rIns="0" bIns="0" rtlCol="0" anchor="t"/>
+          <a:lstStyle/>
+          <a:p>
+            <a:pPr indent="0" marL="0">
+              <a:lnSpc>
+                <a:spcPts val="2400"/>
+              </a:lnSpc>
+              <a:buNone/>
+            </a:pPr>
+            <a:r>
+              <a:rPr lang="en-US" sz="1800" spc="-18" kern="0" dirty="0">
                 <a:solidFill>
                   <a:srgbClr val="FFFFFF"/>
                 </a:solidFill>
@@ -10501,26 +10590,26 @@
               </a:rPr>
               <a:t>“Me conta o que você fez ontem, na ordem.”</a:t>
             </a:r>
-            <a:endParaRPr lang="en-US" sz="1900" dirty="0"/>
-          </a:p>
-        </p:txBody>
-      </p:sp>
-      <p:sp>
-        <p:nvSpPr>
-          <p:cNvPr id="11" name="Shape 9"/>
-          <p:cNvSpPr/>
-          <p:nvPr/>
-        </p:nvSpPr>
-        <p:spPr>
-          <a:xfrm>
-            <a:off x="6400800" y="3584448"/>
-            <a:ext cx="32004" cy="475488"/>
+            <a:endParaRPr lang="en-US" sz="1800" dirty="0"/>
+          </a:p>
+        </p:txBody>
+      </p:sp>
+      <p:sp>
+        <p:nvSpPr>
+          <p:cNvPr id="15" name="Shape 13"/>
+          <p:cNvSpPr/>
+          <p:nvPr/>
+        </p:nvSpPr>
+        <p:spPr>
+          <a:xfrm>
+            <a:off x="6571336" y="3410712"/>
+            <a:ext cx="4669384" cy="10973"/>
           </a:xfrm>
           <a:prstGeom prst="rect">
             <a:avLst/>
           </a:prstGeom>
           <a:solidFill>
-            <a:srgbClr val="E80070"/>
+            <a:srgbClr val="C26A8A"/>
           </a:solidFill>
           <a:ln w="12700">
             <a:solidFill>
@@ -10532,14 +10621,53 @@
       </p:sp>
       <p:sp>
         <p:nvSpPr>
-          <p:cNvPr id="12" name="Text 10"/>
-          <p:cNvSpPr/>
-          <p:nvPr/>
-        </p:nvSpPr>
-        <p:spPr>
-          <a:xfrm>
-            <a:off x="6583680" y="3566160"/>
-            <a:ext cx="4754880" cy="512064"/>
+          <p:cNvPr id="16" name="Text 14"/>
+          <p:cNvSpPr/>
+          <p:nvPr/>
+        </p:nvSpPr>
+        <p:spPr>
+          <a:xfrm>
+            <a:off x="6571336" y="3557016"/>
+            <a:ext cx="4669384" cy="182880"/>
+          </a:xfrm>
+          <a:prstGeom prst="rect">
+            <a:avLst/>
+          </a:prstGeom>
+          <a:noFill/>
+          <a:ln/>
+        </p:spPr>
+        <p:txBody>
+          <a:bodyPr wrap="square" lIns="0" tIns="0" rIns="0" bIns="0" rtlCol="0" anchor="ctr"/>
+          <a:lstStyle/>
+          <a:p>
+            <a:pPr indent="0" marL="0">
+              <a:buNone/>
+            </a:pPr>
+            <a:r>
+              <a:rPr lang="en-US" sz="800" spc="110" kern="0" dirty="0">
+                <a:solidFill>
+                  <a:srgbClr val="C98BAC"/>
+                </a:solidFill>
+                <a:latin typeface="Courier New" pitchFamily="34" charset="0"/>
+                <a:ea typeface="Courier New" pitchFamily="34" charset="-122"/>
+                <a:cs typeface="Courier New" pitchFamily="34" charset="-120"/>
+              </a:rPr>
+              <a:t>A RESPOSTA QUE VEM</a:t>
+            </a:r>
+            <a:endParaRPr lang="en-US" sz="800" dirty="0"/>
+          </a:p>
+        </p:txBody>
+      </p:sp>
+      <p:sp>
+        <p:nvSpPr>
+          <p:cNvPr id="17" name="Text 15"/>
+          <p:cNvSpPr/>
+          <p:nvPr/>
+        </p:nvSpPr>
+        <p:spPr>
+          <a:xfrm>
+            <a:off x="6571336" y="3758184"/>
+            <a:ext cx="4669384" cy="548640"/>
           </a:xfrm>
           <a:prstGeom prst="rect">
             <a:avLst/>
@@ -10553,14 +10681,14 @@
           <a:p>
             <a:pPr indent="0" marL="0">
               <a:lnSpc>
-                <a:spcPts val="1850"/>
-              </a:lnSpc>
-              <a:buNone/>
-            </a:pPr>
-            <a:r>
-              <a:rPr lang="en-US" sz="1300" i="1" dirty="0">
-                <a:solidFill>
-                  <a:srgbClr val="D9C8E4"/>
+                <a:spcPts val="1700"/>
+              </a:lnSpc>
+              <a:buNone/>
+            </a:pPr>
+            <a:r>
+              <a:rPr lang="en-US" sz="1150" i="1" dirty="0">
+                <a:solidFill>
+                  <a:srgbClr val="DCCCE7"/>
                 </a:solidFill>
                 <a:latin typeface="Arial" pitchFamily="34" charset="0"/>
                 <a:ea typeface="Arial" pitchFamily="34" charset="-122"/>
@@ -10568,192 +10696,167 @@
               </a:rPr>
               <a:t>“Chega um e-mail, aí eu jogo no sistema, copio nome e CPF…”</a:t>
             </a:r>
+            <a:endParaRPr lang="en-US" sz="1150" dirty="0"/>
+          </a:p>
+        </p:txBody>
+      </p:sp>
+      <p:sp>
+        <p:nvSpPr>
+          <p:cNvPr id="18" name="Text 16"/>
+          <p:cNvSpPr/>
+          <p:nvPr/>
+        </p:nvSpPr>
+        <p:spPr>
+          <a:xfrm>
+            <a:off x="6571336" y="4361688"/>
+            <a:ext cx="4669384" cy="182880"/>
+          </a:xfrm>
+          <a:prstGeom prst="rect">
+            <a:avLst/>
+          </a:prstGeom>
+          <a:noFill/>
+          <a:ln/>
+        </p:spPr>
+        <p:txBody>
+          <a:bodyPr wrap="square" lIns="0" tIns="0" rIns="0" bIns="0" rtlCol="0" anchor="ctr"/>
+          <a:lstStyle/>
+          <a:p>
+            <a:pPr indent="0" marL="0">
+              <a:buNone/>
+            </a:pPr>
+            <a:r>
+              <a:rPr lang="en-US" sz="800" spc="110" kern="0" dirty="0">
+                <a:solidFill>
+                  <a:srgbClr val="C98BAC"/>
+                </a:solidFill>
+                <a:latin typeface="Courier New" pitchFamily="34" charset="0"/>
+                <a:ea typeface="Courier New" pitchFamily="34" charset="-122"/>
+                <a:cs typeface="Courier New" pitchFamily="34" charset="-120"/>
+              </a:rPr>
+              <a:t>VOCÊ RECEBE</a:t>
+            </a:r>
+            <a:endParaRPr lang="en-US" sz="800" dirty="0"/>
+          </a:p>
+        </p:txBody>
+      </p:sp>
+      <p:sp>
+        <p:nvSpPr>
+          <p:cNvPr id="19" name="Text 17"/>
+          <p:cNvSpPr/>
+          <p:nvPr/>
+        </p:nvSpPr>
+        <p:spPr>
+          <a:xfrm>
+            <a:off x="6571336" y="4562856"/>
+            <a:ext cx="4669384" cy="420624"/>
+          </a:xfrm>
+          <a:prstGeom prst="rect">
+            <a:avLst/>
+          </a:prstGeom>
+          <a:noFill/>
+          <a:ln/>
+        </p:spPr>
+        <p:txBody>
+          <a:bodyPr wrap="square" lIns="0" tIns="0" rIns="0" bIns="0" rtlCol="0" anchor="t"/>
+          <a:lstStyle/>
+          <a:p>
+            <a:pPr indent="0" marL="0">
+              <a:buNone/>
+            </a:pPr>
+            <a:r>
+              <a:rPr lang="en-US" sz="2400" b="1" spc="-53" kern="0" dirty="0">
+                <a:solidFill>
+                  <a:srgbClr val="FF8FC0"/>
+                </a:solidFill>
+                <a:latin typeface="Arial" pitchFamily="34" charset="0"/>
+                <a:ea typeface="Arial" pitchFamily="34" charset="-122"/>
+                <a:cs typeface="Arial" pitchFamily="34" charset="-120"/>
+              </a:rPr>
+              <a:t>o processo</a:t>
+            </a:r>
+            <a:endParaRPr lang="en-US" sz="2400" dirty="0"/>
+          </a:p>
+        </p:txBody>
+      </p:sp>
+      <p:sp>
+        <p:nvSpPr>
+          <p:cNvPr id="20" name="Text 18"/>
+          <p:cNvSpPr/>
+          <p:nvPr/>
+        </p:nvSpPr>
+        <p:spPr>
+          <a:xfrm>
+            <a:off x="658368" y="5257800"/>
+            <a:ext cx="10874959" cy="548640"/>
+          </a:xfrm>
+          <a:prstGeom prst="rect">
+            <a:avLst/>
+          </a:prstGeom>
+          <a:noFill/>
+          <a:ln/>
+        </p:spPr>
+        <p:txBody>
+          <a:bodyPr wrap="square" lIns="0" tIns="0" rIns="0" bIns="0" rtlCol="0" anchor="t"/>
+          <a:lstStyle/>
+          <a:p>
+            <a:pPr indent="0" marL="0">
+              <a:lnSpc>
+                <a:spcPts val="1950"/>
+              </a:lnSpc>
+              <a:buNone/>
+            </a:pPr>
+            <a:r>
+              <a:rPr lang="en-US" sz="1300" dirty="0">
+                <a:solidFill>
+                  <a:srgbClr val="C9B6D4"/>
+                </a:solidFill>
+                <a:latin typeface="Arial" pitchFamily="34" charset="0"/>
+                <a:ea typeface="Arial" pitchFamily="34" charset="-122"/>
+                <a:cs typeface="Arial" pitchFamily="34" charset="-120"/>
+              </a:rPr>
+              <a:t>A segunda não é mais esperta — é mais </a:t>
+            </a:r>
+            <a:pPr indent="0" marL="0">
+              <a:lnSpc>
+                <a:spcPts val="1950"/>
+              </a:lnSpc>
+              <a:buNone/>
+            </a:pPr>
+            <a:r>
+              <a:rPr lang="en-US" sz="1300" b="1" dirty="0">
+                <a:solidFill>
+                  <a:srgbClr val="FFFFFF"/>
+                </a:solidFill>
+                <a:latin typeface="Arial" pitchFamily="34" charset="0"/>
+                <a:ea typeface="Arial" pitchFamily="34" charset="-122"/>
+                <a:cs typeface="Arial" pitchFamily="34" charset="-120"/>
+              </a:rPr>
+              <a:t>fácil de responder</a:t>
+            </a:r>
+            <a:pPr indent="0" marL="0">
+              <a:lnSpc>
+                <a:spcPts val="1950"/>
+              </a:lnSpc>
+              <a:buNone/>
+            </a:pPr>
+            <a:r>
+              <a:rPr lang="en-US" sz="1300" dirty="0">
+                <a:solidFill>
+                  <a:srgbClr val="C9B6D4"/>
+                </a:solidFill>
+                <a:latin typeface="Arial" pitchFamily="34" charset="0"/>
+                <a:ea typeface="Arial" pitchFamily="34" charset="-122"/>
+                <a:cs typeface="Arial" pitchFamily="34" charset="-120"/>
+              </a:rPr>
+              <a:t>. A primeira pede um julgamento sobre o próprio trabalho; a segunda pede só uma memória.</a:t>
+            </a:r>
             <a:endParaRPr lang="en-US" sz="1300" dirty="0"/>
           </a:p>
         </p:txBody>
       </p:sp>
       <p:sp>
         <p:nvSpPr>
-          <p:cNvPr id="13" name="Text 11"/>
-          <p:cNvSpPr/>
-          <p:nvPr/>
-        </p:nvSpPr>
-        <p:spPr>
-          <a:xfrm>
-            <a:off x="6400800" y="4206240"/>
-            <a:ext cx="4937760" cy="512064"/>
-          </a:xfrm>
-          <a:prstGeom prst="rect">
-            <a:avLst/>
-          </a:prstGeom>
-          <a:noFill/>
-          <a:ln/>
-        </p:spPr>
-        <p:txBody>
-          <a:bodyPr wrap="square" lIns="0" tIns="0" rIns="0" bIns="0" rtlCol="0" anchor="t"/>
-          <a:lstStyle/>
-          <a:p>
-            <a:pPr indent="0" marL="0">
-              <a:lnSpc>
-                <a:spcPts val="1900"/>
-              </a:lnSpc>
-              <a:buNone/>
-            </a:pPr>
-            <a:r>
-              <a:rPr lang="en-US" sz="1250" dirty="0">
-                <a:solidFill>
-                  <a:srgbClr val="EDE4F3"/>
-                </a:solidFill>
-                <a:latin typeface="Arial" pitchFamily="34" charset="0"/>
-                <a:ea typeface="Arial" pitchFamily="34" charset="-122"/>
-                <a:cs typeface="Arial" pitchFamily="34" charset="-120"/>
-              </a:rPr>
-              <a:t>Vêm </a:t>
-            </a:r>
-            <a:pPr indent="0" marL="0">
-              <a:lnSpc>
-                <a:spcPts val="1900"/>
-              </a:lnSpc>
-              <a:buNone/>
-            </a:pPr>
-            <a:r>
-              <a:rPr lang="en-US" sz="1250" b="1" dirty="0">
-                <a:solidFill>
-                  <a:srgbClr val="FFFFFF"/>
-                </a:solidFill>
-                <a:latin typeface="Arial" pitchFamily="34" charset="0"/>
-                <a:ea typeface="Arial" pitchFamily="34" charset="-122"/>
-                <a:cs typeface="Arial" pitchFamily="34" charset="-120"/>
-              </a:rPr>
-              <a:t>as etapas reais</a:t>
-            </a:r>
-            <a:pPr indent="0" marL="0">
-              <a:lnSpc>
-                <a:spcPts val="1900"/>
-              </a:lnSpc>
-              <a:buNone/>
-            </a:pPr>
-            <a:r>
-              <a:rPr lang="en-US" sz="1250" dirty="0">
-                <a:solidFill>
-                  <a:srgbClr val="EDE4F3"/>
-                </a:solidFill>
-                <a:latin typeface="Arial" pitchFamily="34" charset="0"/>
-                <a:ea typeface="Arial" pitchFamily="34" charset="-122"/>
-                <a:cs typeface="Arial" pitchFamily="34" charset="-120"/>
-              </a:rPr>
-              <a:t>, na ordem em que acontecem.</a:t>
-            </a:r>
-            <a:endParaRPr lang="en-US" sz="1250" dirty="0"/>
-          </a:p>
-        </p:txBody>
-      </p:sp>
-      <p:sp>
-        <p:nvSpPr>
-          <p:cNvPr id="14" name="Shape 12"/>
-          <p:cNvSpPr/>
-          <p:nvPr/>
-        </p:nvSpPr>
-        <p:spPr>
-          <a:xfrm>
-            <a:off x="658368" y="4919472"/>
-            <a:ext cx="10874959" cy="10973"/>
-          </a:xfrm>
-          <a:prstGeom prst="rect">
-            <a:avLst/>
-          </a:prstGeom>
-          <a:solidFill>
-            <a:srgbClr val="FFFFFF">
-              <a:alpha val="16000"/>
-            </a:srgbClr>
-          </a:solidFill>
-          <a:ln w="12700">
-            <a:solidFill>
-              <a:srgbClr val="333333"/>
-            </a:solidFill>
-            <a:prstDash val="solid"/>
-          </a:ln>
-        </p:spPr>
-      </p:sp>
-      <p:sp>
-        <p:nvSpPr>
-          <p:cNvPr id="15" name="Text 13"/>
-          <p:cNvSpPr/>
-          <p:nvPr/>
-        </p:nvSpPr>
-        <p:spPr>
-          <a:xfrm>
-            <a:off x="658368" y="5120640"/>
-            <a:ext cx="10874959" cy="566928"/>
-          </a:xfrm>
-          <a:prstGeom prst="rect">
-            <a:avLst/>
-          </a:prstGeom>
-          <a:noFill/>
-          <a:ln/>
-        </p:spPr>
-        <p:txBody>
-          <a:bodyPr wrap="square" lIns="0" tIns="0" rIns="0" bIns="0" rtlCol="0" anchor="t"/>
-          <a:lstStyle/>
-          <a:p>
-            <a:pPr indent="0" marL="0">
-              <a:lnSpc>
-                <a:spcPts val="1900"/>
-              </a:lnSpc>
-              <a:buNone/>
-            </a:pPr>
-            <a:r>
-              <a:rPr lang="en-US" sz="1350" dirty="0">
-                <a:solidFill>
-                  <a:srgbClr val="C9B6D4"/>
-                </a:solidFill>
-                <a:latin typeface="Arial" pitchFamily="34" charset="0"/>
-                <a:ea typeface="Arial" pitchFamily="34" charset="-122"/>
-                <a:cs typeface="Arial" pitchFamily="34" charset="-120"/>
-              </a:rPr>
-              <a:t>A segunda não é uma pergunta mais esperta: é uma pergunta mais </a:t>
-            </a:r>
-            <a:pPr indent="0" marL="0">
-              <a:lnSpc>
-                <a:spcPts val="1900"/>
-              </a:lnSpc>
-              <a:buNone/>
-            </a:pPr>
-            <a:r>
-              <a:rPr lang="en-US" sz="1350" b="1" dirty="0">
-                <a:solidFill>
-                  <a:srgbClr val="FFFFFF"/>
-                </a:solidFill>
-                <a:latin typeface="Arial" pitchFamily="34" charset="0"/>
-                <a:ea typeface="Arial" pitchFamily="34" charset="-122"/>
-                <a:cs typeface="Arial" pitchFamily="34" charset="-120"/>
-              </a:rPr>
-              <a:t>fácil de responder</a:t>
-            </a:r>
-            <a:pPr indent="0" marL="0">
-              <a:lnSpc>
-                <a:spcPts val="1900"/>
-              </a:lnSpc>
-              <a:buNone/>
-            </a:pPr>
-            <a:r>
-              <a:rPr lang="en-US" sz="1350" dirty="0">
-                <a:solidFill>
-                  <a:srgbClr val="C9B6D4"/>
-                </a:solidFill>
-                <a:latin typeface="Arial" pitchFamily="34" charset="0"/>
-                <a:ea typeface="Arial" pitchFamily="34" charset="-122"/>
-                <a:cs typeface="Arial" pitchFamily="34" charset="-120"/>
-              </a:rPr>
-              <a:t>. A primeira pede um julgamento sobre o próprio trabalho; a segunda pede só uma memória — e memória sai mais fiel.</a:t>
-            </a:r>
-            <a:endParaRPr lang="en-US" sz="1350" dirty="0"/>
-          </a:p>
-        </p:txBody>
-      </p:sp>
-      <p:sp>
-        <p:nvSpPr>
-          <p:cNvPr id="16" name="Text 14"/>
+          <p:cNvPr id="21" name="Text 19"/>
           <p:cNvSpPr/>
           <p:nvPr/>
         </p:nvSpPr>

</xml_diff>

<commit_message>
Ask 'como voce faz esse processo hoje?' instead of 'o que voce fez ontem'
Slide 3 carries the short headline form; slide 4 keeps the ordering cue
('Me conta na ordem') since it is the interview script.

The rationale had to move with it. The old line argued memory beats
judgement, which only held for a question about yesterday. The new one
argues what is actually true of the new phrasing: the first question is
about the future the person imagines, the second about the present they
execute — and the present is observable, so it comes back more faithful.

Co-Authored-By: Claude Opus 5 <noreply@anthropic.com>
Claude-Session: https://claude.ai/code/session_01MoQxsSguKqzeKVWx2SGcrP
</commit_message>
<xml_diff>
--- a/talks/serasa-ia-automacao/deck.pptx
+++ b/talks/serasa-ia-automacao/deck.pptx
@@ -1132,7 +1132,7 @@
           <a:p>
             <a:r>
               <a:rPr lang="en-US" dirty="0"/>
-              <a:t>As duas cartas têm a mesma anatomia de propósito: a plateia compara direto o desfecho, 'uma solução' contra 'o processo'. Não é que a pergunta 1 seja proibida — ela pede um julgamento, e a 2 pede uma memória. ~1,5 min.</a:t>
+              <a:t>As duas cartas têm a mesma anatomia de propósito: a plateia compara direto o desfecho, 'uma solução' contra 'o processo'. Não é que a pergunta 1 seja proibida — ela pergunta sobre o futuro que a pessoa imagina, e a 2 pergunta sobre o presente que ela executa. ~1,5 min.</a:t>
             </a:r>
             <a:endParaRPr lang="en-US" dirty="0"/>
           </a:p>
@@ -10588,7 +10588,7 @@
                 <a:ea typeface="Arial" pitchFamily="34" charset="-122"/>
                 <a:cs typeface="Arial" pitchFamily="34" charset="-120"/>
               </a:rPr>
-              <a:t>“Me conta o que você fez ontem, na ordem.”</a:t>
+              <a:t>“Como você faz esse processo hoje?”</a:t>
             </a:r>
             <a:endParaRPr lang="en-US" sz="1800" dirty="0"/>
           </a:p>
@@ -10814,7 +10814,7 @@
                 <a:ea typeface="Arial" pitchFamily="34" charset="-122"/>
                 <a:cs typeface="Arial" pitchFamily="34" charset="-120"/>
               </a:rPr>
-              <a:t>A segunda não é mais esperta — é mais </a:t>
+              <a:t>A segunda não é mais esperta — ela só pergunta sobre o </a:t>
             </a:r>
             <a:pPr indent="0" marL="0">
               <a:lnSpc>
@@ -10831,7 +10831,7 @@
                 <a:ea typeface="Arial" pitchFamily="34" charset="-122"/>
                 <a:cs typeface="Arial" pitchFamily="34" charset="-120"/>
               </a:rPr>
-              <a:t>fácil de responder</a:t>
+              <a:t>presente</a:t>
             </a:r>
             <a:pPr indent="0" marL="0">
               <a:lnSpc>
@@ -10848,7 +10848,7 @@
                 <a:ea typeface="Arial" pitchFamily="34" charset="-122"/>
                 <a:cs typeface="Arial" pitchFamily="34" charset="-120"/>
               </a:rPr>
-              <a:t>. A primeira pede um julgamento sobre o próprio trabalho; a segunda pede só uma memória.</a:t>
+              <a:t>. A primeira pede um palpite sobre o que deveria mudar; a segunda pede a descrição do que já acontece, e isso qualquer pessoa dá com precisão.</a:t>
             </a:r>
             <a:endParaRPr lang="en-US" sz="1300" dirty="0"/>
           </a:p>
@@ -11180,7 +11180,7 @@
                 <a:ea typeface="Arial" pitchFamily="34" charset="-122"/>
                 <a:cs typeface="Arial" pitchFamily="34" charset="-120"/>
               </a:rPr>
-              <a:t>“Me conta o que você fez ontem, na ordem.”</a:t>
+              <a:t>“Como você faz esse processo hoje? Me conta na ordem.”</a:t>
             </a:r>
             <a:endParaRPr lang="en-US" sz="1150" dirty="0"/>
           </a:p>

</xml_diff>

<commit_message>
Point the kit QR at the Drive folder and neutralise the photo slot
The QR now encodes the shared Drive folder, and make_qr.py decodes what it
just produced and compares it against the source URL before declaring
success — a wrong QR on a slide only reveals itself in front of the room.

The photo is going in by hand in Google Slides, so its placeholder stopped
being a magenta dashed warning aimed at me and became a plain lavender
square marked FOTO: presentable as-is if it never gets replaced, and
obvious to select and swap.

Co-Authored-By: Claude Opus 5 <noreply@anthropic.com>
Claude-Session: https://claude.ai/code/session_01MoQxsSguKqzeKVWx2SGcrP
</commit_message>
<xml_diff>
--- a/talks/serasa-ia-automacao/deck.pptx
+++ b/talks/serasa-ia-automacao/deck.pptx
@@ -1044,7 +1044,7 @@
             <a:r>
               <a:rPr lang="en-US" dirty="0"/>
               <a:t>Credencial em 30 segundos, não currículo. A frase do painel escuro é a tese da palestra inteira: script / IA / pessoa. Ela volta no slide 8. ~1 min.
-PENDENTE: salvar a foto em assets/bruno.jpg e rodar node make_pptx.js de novo.</a:t>
+A FOTO ENTRA À MÃO: selecione o quadrado lavanda e substitua por Imagem. Ou salve em assets/bruno.jpg e rode node make_pptx.js.</a:t>
             </a:r>
             <a:endParaRPr lang="en-US" dirty="0"/>
           </a:p>
@@ -10050,13 +10050,12 @@
             </a:avLst>
           </a:prstGeom>
           <a:solidFill>
-            <a:srgbClr val="FEF6FA"/>
+            <a:srgbClr val="F4F0F9"/>
           </a:solidFill>
-          <a:ln w="15875">
+          <a:ln w="12700">
             <a:solidFill>
-              <a:srgbClr val="E80070"/>
+              <a:srgbClr val="EAE3F3"/>
             </a:solidFill>
-            <a:prstDash val="dash"/>
           </a:ln>
         </p:spPr>
         <p:txBody>
@@ -10064,43 +10063,20 @@
           <a:lstStyle/>
           <a:p>
             <a:pPr algn="ctr" indent="0" marL="0">
-              <a:lnSpc>
-                <a:spcPts val="1400"/>
-              </a:lnSpc>
-              <a:buNone/>
-            </a:pPr>
-            <a:r>
-              <a:rPr lang="en-US" sz="950" i="1" dirty="0">
-                <a:solidFill>
-                  <a:srgbClr val="A08BAA"/>
+              <a:buNone/>
+            </a:pPr>
+            <a:r>
+              <a:rPr lang="en-US" sz="1100" spc="160" kern="0" dirty="0">
+                <a:solidFill>
+                  <a:srgbClr val="B9AFC9"/>
                 </a:solidFill>
                 <a:latin typeface="Courier New" pitchFamily="34" charset="0"/>
                 <a:ea typeface="Courier New" pitchFamily="34" charset="-122"/>
                 <a:cs typeface="Courier New" pitchFamily="34" charset="-120"/>
               </a:rPr>
-              <a:t>foto: salve em</a:t>
-            </a:r>
-            <a:endParaRPr lang="en-US" sz="950" dirty="0"/>
-          </a:p>
-          <a:p>
-            <a:pPr algn="ctr" indent="0" marL="0">
-              <a:lnSpc>
-                <a:spcPts val="1400"/>
-              </a:lnSpc>
-              <a:buNone/>
-            </a:pPr>
-            <a:r>
-              <a:rPr lang="en-US" sz="950" i="1" dirty="0">
-                <a:solidFill>
-                  <a:srgbClr val="A08BAA"/>
-                </a:solidFill>
-                <a:latin typeface="Courier New" pitchFamily="34" charset="0"/>
-                <a:ea typeface="Courier New" pitchFamily="34" charset="-122"/>
-                <a:cs typeface="Courier New" pitchFamily="34" charset="-120"/>
-              </a:rPr>
-              <a:t>assets/bruno.jpg</a:t>
-            </a:r>
-            <a:endParaRPr lang="en-US" sz="950" dirty="0"/>
+              <a:t>FOTO</a:t>
+            </a:r>
+            <a:endParaRPr lang="en-US" sz="1100" dirty="0"/>
           </a:p>
         </p:txBody>
       </p:sp>

</xml_diff>